<commit_message>
Embed measurement in the Physical AI curriculum
</commit_message>
<xml_diff>
--- a/outputs/arduino-qualcomm-physical-ai-engineering-pitch.pptx
+++ b/outputs/arduino-qualcomm-physical-ai-engineering-pitch.pptx
@@ -2,30 +2,30 @@
 <file path=ppt/presentation.xml><?xml version="1.0" encoding="utf-8"?>
 <p:presentation xmlns:p="http://schemas.openxmlformats.org/presentationml/2006/main">
   <p:sldMasterIdLst>
-    <p:sldMasterId xmlns:r="http://schemas.openxmlformats.org/officeDocument/2006/relationships" id="2147483648" r:id="R3a483cb659224512"/>
+    <p:sldMasterId xmlns:r="http://schemas.openxmlformats.org/officeDocument/2006/relationships" id="2147483648" r:id="Rff5ed74e94bf4c40"/>
   </p:sldMasterIdLst>
   <p:notesMasterIdLst>
-    <p:notesMasterId xmlns:r="http://schemas.openxmlformats.org/officeDocument/2006/relationships" r:id="R237c4cad45ee4611"/>
+    <p:notesMasterId xmlns:r="http://schemas.openxmlformats.org/officeDocument/2006/relationships" r:id="R5e118f2897454c72"/>
   </p:notesMasterIdLst>
   <p:sldIdLst>
-    <p:sldId xmlns:r="http://schemas.openxmlformats.org/officeDocument/2006/relationships" id="256" r:id="Rd1f25b905d6445eb"/>
-    <p:sldId xmlns:r="http://schemas.openxmlformats.org/officeDocument/2006/relationships" id="257" r:id="R446ada5516504ba8"/>
-    <p:sldId xmlns:r="http://schemas.openxmlformats.org/officeDocument/2006/relationships" id="258" r:id="R3af813711ec44d23"/>
-    <p:sldId xmlns:r="http://schemas.openxmlformats.org/officeDocument/2006/relationships" id="259" r:id="R0c58df38d8364665"/>
-    <p:sldId xmlns:r="http://schemas.openxmlformats.org/officeDocument/2006/relationships" id="260" r:id="R1074f3bb1bac4c14"/>
-    <p:sldId xmlns:r="http://schemas.openxmlformats.org/officeDocument/2006/relationships" id="261" r:id="Raee0a9259b414c56"/>
-    <p:sldId xmlns:r="http://schemas.openxmlformats.org/officeDocument/2006/relationships" id="262" r:id="Rf342701d484b498f"/>
-    <p:sldId xmlns:r="http://schemas.openxmlformats.org/officeDocument/2006/relationships" id="263" r:id="R738f4cfdf3624fe9"/>
-    <p:sldId xmlns:r="http://schemas.openxmlformats.org/officeDocument/2006/relationships" id="264" r:id="Re0c2f0df415647d8"/>
-    <p:sldId xmlns:r="http://schemas.openxmlformats.org/officeDocument/2006/relationships" id="265" r:id="R12d4acda6ef84188"/>
-    <p:sldId xmlns:r="http://schemas.openxmlformats.org/officeDocument/2006/relationships" id="266" r:id="Rf294aa38369c41f9"/>
-    <p:sldId xmlns:r="http://schemas.openxmlformats.org/officeDocument/2006/relationships" id="267" r:id="R45beea0569fc479e"/>
-    <p:sldId xmlns:r="http://schemas.openxmlformats.org/officeDocument/2006/relationships" id="268" r:id="Radc0db21bd3f4b00"/>
-    <p:sldId xmlns:r="http://schemas.openxmlformats.org/officeDocument/2006/relationships" id="269" r:id="R9c46f075e35f4a32"/>
-    <p:sldId xmlns:r="http://schemas.openxmlformats.org/officeDocument/2006/relationships" id="270" r:id="R3c562d2c446648cf"/>
-    <p:sldId xmlns:r="http://schemas.openxmlformats.org/officeDocument/2006/relationships" id="271" r:id="R6de71623a8dd4620"/>
-    <p:sldId xmlns:r="http://schemas.openxmlformats.org/officeDocument/2006/relationships" id="272" r:id="Ra7fd102a6f71454a"/>
-    <p:sldId xmlns:r="http://schemas.openxmlformats.org/officeDocument/2006/relationships" id="273" r:id="R6d7a9100f8f44541"/>
+    <p:sldId xmlns:r="http://schemas.openxmlformats.org/officeDocument/2006/relationships" id="256" r:id="R2701b27bacdd4708"/>
+    <p:sldId xmlns:r="http://schemas.openxmlformats.org/officeDocument/2006/relationships" id="257" r:id="R7634eda0abd443b8"/>
+    <p:sldId xmlns:r="http://schemas.openxmlformats.org/officeDocument/2006/relationships" id="258" r:id="Rd88cfa5163024855"/>
+    <p:sldId xmlns:r="http://schemas.openxmlformats.org/officeDocument/2006/relationships" id="259" r:id="R6a3ebd65747f40a0"/>
+    <p:sldId xmlns:r="http://schemas.openxmlformats.org/officeDocument/2006/relationships" id="260" r:id="R4f2a4dc369c945cc"/>
+    <p:sldId xmlns:r="http://schemas.openxmlformats.org/officeDocument/2006/relationships" id="261" r:id="R658fbfee08414c68"/>
+    <p:sldId xmlns:r="http://schemas.openxmlformats.org/officeDocument/2006/relationships" id="262" r:id="Rdee5dc7e44224bbf"/>
+    <p:sldId xmlns:r="http://schemas.openxmlformats.org/officeDocument/2006/relationships" id="263" r:id="R2f88d9b5c6344ede"/>
+    <p:sldId xmlns:r="http://schemas.openxmlformats.org/officeDocument/2006/relationships" id="264" r:id="R0c139f8b563f4349"/>
+    <p:sldId xmlns:r="http://schemas.openxmlformats.org/officeDocument/2006/relationships" id="265" r:id="R78bbb442347643e0"/>
+    <p:sldId xmlns:r="http://schemas.openxmlformats.org/officeDocument/2006/relationships" id="266" r:id="Rdac446477ed74c54"/>
+    <p:sldId xmlns:r="http://schemas.openxmlformats.org/officeDocument/2006/relationships" id="267" r:id="Ra3ae02b570434f66"/>
+    <p:sldId xmlns:r="http://schemas.openxmlformats.org/officeDocument/2006/relationships" id="268" r:id="R1ef8dbe2acc74610"/>
+    <p:sldId xmlns:r="http://schemas.openxmlformats.org/officeDocument/2006/relationships" id="269" r:id="Rc502013b2c3a4ea5"/>
+    <p:sldId xmlns:r="http://schemas.openxmlformats.org/officeDocument/2006/relationships" id="270" r:id="R0333888b8e87419e"/>
+    <p:sldId xmlns:r="http://schemas.openxmlformats.org/officeDocument/2006/relationships" id="271" r:id="R08419b6c5ca14ca8"/>
+    <p:sldId xmlns:r="http://schemas.openxmlformats.org/officeDocument/2006/relationships" id="272" r:id="Rb7fc33d446ba4d2f"/>
+    <p:sldId xmlns:r="http://schemas.openxmlformats.org/officeDocument/2006/relationships" id="273" r:id="Ra9505ab3ed394ea3"/>
   </p:sldIdLst>
   <p:sldSz cx="12192000" cy="6858000"/>
   <p:notesSz cx="6858000" cy="9144000"/>
@@ -764,7 +764,7 @@
           <a:lstStyle xmlns:a="http://schemas.openxmlformats.org/drawingml/2006/main"/>
           <a:p xmlns:a="http://schemas.openxmlformats.org/drawingml/2006/main">
             <a:r>
-              <a:t>loopbench is where curriculum value becomes durable software and a portable protocol. No result is shown here. The slide shows the measurement contract and reporting shape.</a:t>
+              <a:t>The curriculum carries a common evidence format without promising a standalone measurement product. The slide shows the measurement contract and reporting shape embedded in each lab.</a:t>
             </a:r>
           </a:p>
         </p:txBody>
@@ -1674,7 +1674,7 @@
           <a:lstStyle xmlns:a="http://schemas.openxmlformats.org/drawingml/2006/main"/>
           <a:p xmlns:a="http://schemas.openxmlformats.org/drawingml/2006/main">
             <a:r>
-              <a:t>This is the hinge of the pitch. Reachy recruits and grounds. UNO Q reproduces the mechanism. loopbench turns the measurement method into a portable product.</a:t>
+              <a:t>This is the hinge of the pitch. Reachy recruits and grounds. UNO Q reproduces the mechanism. Measurement remains inside every lab and the reference runtime rather than becoming a third product.</a:t>
             </a:r>
           </a:p>
         </p:txBody>
@@ -1812,7 +1812,7 @@
   </p:cSld>
   <p:clrMap bg1="lt1" tx1="dk1" bg2="lt2" tx2="dk2" accent1="accent1" accent2="accent2" accent3="accent3" accent4="accent4" accent5="accent5" accent6="accent6" hlink="hlink" folHlink="folHlink"/>
   <p:sldLayoutIdLst>
-    <p:sldLayoutId xmlns:r="http://schemas.openxmlformats.org/officeDocument/2006/relationships" id="2147483649" r:id="Rb141e336890e42e7"/>
+    <p:sldLayoutId xmlns:r="http://schemas.openxmlformats.org/officeDocument/2006/relationships" id="2147483649" r:id="R4b9a6deb1e8f4a00"/>
   </p:sldLayoutIdLst>
   <p:txStyles>
     <p:titleStyle>
@@ -2360,14 +2360,14 @@
       </p:grpSpPr>
       <p:pic>
         <p:nvPicPr>
-          <p:cNvPr id="10" name=""/>
+          <p:cNvPr id="11" name=""/>
           <p:cNvPicPr>
             <a:picLocks xmlns:a="http://schemas.openxmlformats.org/drawingml/2006/main" noChangeAspect="1"/>
           </p:cNvPicPr>
           <p:nvPr/>
         </p:nvPicPr>
         <p:blipFill>
-          <a:blip xmlns:r="http://schemas.openxmlformats.org/officeDocument/2006/relationships" xmlns:a="http://schemas.openxmlformats.org/drawingml/2006/main" r:embed="R26b00a0eb1b34d31"/>
+          <a:blip xmlns:r="http://schemas.openxmlformats.org/officeDocument/2006/relationships" xmlns:a="http://schemas.openxmlformats.org/drawingml/2006/main" r:embed="R6651595771934201"/>
           <a:srcRect xmlns:a="http://schemas.openxmlformats.org/drawingml/2006/main" l="13889" t="0" r="13889" b="0"/>
           <a:stretch xmlns:a="http://schemas.openxmlformats.org/drawingml/2006/main">
             <a:fillRect l="0" t="0" r="0" b="0"/>
@@ -2444,6 +2444,7 @@
           <a:lstStyle xmlns:a="http://schemas.openxmlformats.org/drawingml/2006/main"/>
           <a:p xmlns:a="http://schemas.openxmlformats.org/drawingml/2006/main">
             <a:pPr algn="l">
+              <a:buNone/>
               <a:defRPr sz="975" b="1">
                 <a:solidFill>
                   <a:srgbClr val="18A999"/>
@@ -2494,6 +2495,7 @@
           <a:lstStyle xmlns:a="http://schemas.openxmlformats.org/drawingml/2006/main"/>
           <a:p xmlns:a="http://schemas.openxmlformats.org/drawingml/2006/main">
             <a:pPr algn="l">
+              <a:buNone/>
               <a:defRPr sz="4050" b="1">
                 <a:solidFill>
                   <a:srgbClr val="FFFFFF"/>
@@ -2511,6 +2513,7 @@
           </a:p>
           <a:p xmlns:a="http://schemas.openxmlformats.org/drawingml/2006/main">
             <a:pPr algn="l">
+              <a:buNone/>
               <a:defRPr sz="4050" b="1">
                 <a:solidFill>
                   <a:srgbClr val="FFFFFF"/>
@@ -2561,6 +2564,7 @@
           <a:lstStyle xmlns:a="http://schemas.openxmlformats.org/drawingml/2006/main"/>
           <a:p xmlns:a="http://schemas.openxmlformats.org/drawingml/2006/main">
             <a:pPr algn="l">
+              <a:buNone/>
               <a:defRPr sz="1875" b="0">
                 <a:solidFill>
                   <a:srgbClr val="DDE4EE"/>
@@ -2578,6 +2582,7 @@
           </a:p>
           <a:p xmlns:a="http://schemas.openxmlformats.org/drawingml/2006/main">
             <a:pPr algn="l">
+              <a:buNone/>
               <a:defRPr sz="1875" b="0">
                 <a:solidFill>
                   <a:srgbClr val="DDE4EE"/>
@@ -2659,6 +2664,7 @@
           <a:lstStyle xmlns:a="http://schemas.openxmlformats.org/drawingml/2006/main"/>
           <a:p xmlns:a="http://schemas.openxmlformats.org/drawingml/2006/main">
             <a:pPr algn="l">
+              <a:buNone/>
               <a:defRPr sz="1425" b="1">
                 <a:solidFill>
                   <a:srgbClr val="FFFFFF"/>
@@ -2709,6 +2715,7 @@
           <a:lstStyle xmlns:a="http://schemas.openxmlformats.org/drawingml/2006/main"/>
           <a:p xmlns:a="http://schemas.openxmlformats.org/drawingml/2006/main">
             <a:pPr algn="l">
+              <a:buNone/>
               <a:defRPr sz="1200" b="0">
                 <a:solidFill>
                   <a:srgbClr val="C8D0DC"/>
@@ -2721,7 +2728,7 @@
                   <a:srgbClr val="C8D0DC"/>
                 </a:solidFill>
               </a:rPr>
-              <a:t>Curriculum · labs · measurement instrument · executive technical leadership</a:t>
+              <a:t>Curriculum · labs · reference system · executive technical leadership</a:t>
             </a:r>
           </a:p>
         </p:txBody>
@@ -2759,6 +2766,7 @@
           <a:lstStyle xmlns:a="http://schemas.openxmlformats.org/drawingml/2006/main"/>
           <a:p xmlns:a="http://schemas.openxmlformats.org/drawingml/2006/main">
             <a:pPr algn="l">
+              <a:buNone/>
               <a:defRPr sz="975" b="0">
                 <a:solidFill>
                   <a:srgbClr val="AEB8C8"/>
@@ -2838,6 +2846,7 @@
           <a:lstStyle xmlns:a="http://schemas.openxmlformats.org/drawingml/2006/main"/>
           <a:p xmlns:a="http://schemas.openxmlformats.org/drawingml/2006/main">
             <a:pPr algn="r">
+              <a:buNone/>
               <a:defRPr sz="825" b="1">
                 <a:solidFill>
                   <a:srgbClr val="687386"/>
@@ -2888,6 +2897,7 @@
           <a:lstStyle xmlns:a="http://schemas.openxmlformats.org/drawingml/2006/main"/>
           <a:p xmlns:a="http://schemas.openxmlformats.org/drawingml/2006/main">
             <a:pPr algn="l">
+              <a:buNone/>
               <a:defRPr sz="900" b="1">
                 <a:solidFill>
                   <a:srgbClr val="18A999"/>
@@ -2938,6 +2948,7 @@
           <a:lstStyle xmlns:a="http://schemas.openxmlformats.org/drawingml/2006/main"/>
           <a:p xmlns:a="http://schemas.openxmlformats.org/drawingml/2006/main">
             <a:pPr algn="l">
+              <a:buNone/>
               <a:defRPr sz="2850" b="1">
                 <a:solidFill>
                   <a:srgbClr val="1B2A4A"/>
@@ -2988,6 +2999,7 @@
           <a:lstStyle xmlns:a="http://schemas.openxmlformats.org/drawingml/2006/main"/>
           <a:p xmlns:a="http://schemas.openxmlformats.org/drawingml/2006/main">
             <a:pPr algn="l">
+              <a:buNone/>
               <a:defRPr sz="1425" b="0">
                 <a:solidFill>
                   <a:srgbClr val="687386"/>
@@ -3100,6 +3112,7 @@
           <a:lstStyle xmlns:a="http://schemas.openxmlformats.org/drawingml/2006/main"/>
           <a:p xmlns:a="http://schemas.openxmlformats.org/drawingml/2006/main">
             <a:pPr algn="ctr">
+              <a:buNone/>
               <a:defRPr sz="2400" b="0">
                 <a:solidFill>
                   <a:srgbClr val="C0562B"/>
@@ -3150,6 +3163,7 @@
           <a:lstStyle xmlns:a="http://schemas.openxmlformats.org/drawingml/2006/main"/>
           <a:p xmlns:a="http://schemas.openxmlformats.org/drawingml/2006/main">
             <a:pPr algn="ctr">
+              <a:buNone/>
               <a:defRPr sz="2400" b="0">
                 <a:solidFill>
                   <a:srgbClr val="18A999"/>
@@ -3235,6 +3249,7 @@
           <a:lstStyle xmlns:a="http://schemas.openxmlformats.org/drawingml/2006/main"/>
           <a:p xmlns:a="http://schemas.openxmlformats.org/drawingml/2006/main">
             <a:pPr algn="l">
+              <a:buNone/>
               <a:defRPr sz="975" b="1">
                 <a:solidFill>
                   <a:srgbClr val="C0562B"/>
@@ -3285,6 +3300,7 @@
           <a:lstStyle xmlns:a="http://schemas.openxmlformats.org/drawingml/2006/main"/>
           <a:p xmlns:a="http://schemas.openxmlformats.org/drawingml/2006/main">
             <a:pPr algn="l">
+              <a:buNone/>
               <a:defRPr sz="1500" b="1">
                 <a:solidFill>
                   <a:srgbClr val="C0562B"/>
@@ -3335,6 +3351,7 @@
           <a:lstStyle xmlns:a="http://schemas.openxmlformats.org/drawingml/2006/main"/>
           <a:p xmlns:a="http://schemas.openxmlformats.org/drawingml/2006/main">
             <a:pPr algn="l">
+              <a:buNone/>
               <a:defRPr sz="1350" b="0">
                 <a:solidFill>
                   <a:srgbClr val="3F4A59"/>
@@ -3420,6 +3437,7 @@
           <a:lstStyle xmlns:a="http://schemas.openxmlformats.org/drawingml/2006/main"/>
           <a:p xmlns:a="http://schemas.openxmlformats.org/drawingml/2006/main">
             <a:pPr algn="l">
+              <a:buNone/>
               <a:defRPr sz="975" b="1">
                 <a:solidFill>
                   <a:srgbClr val="1B2A4A"/>
@@ -3470,6 +3488,7 @@
           <a:lstStyle xmlns:a="http://schemas.openxmlformats.org/drawingml/2006/main"/>
           <a:p xmlns:a="http://schemas.openxmlformats.org/drawingml/2006/main">
             <a:pPr algn="l">
+              <a:buNone/>
               <a:defRPr sz="1500" b="1">
                 <a:solidFill>
                   <a:srgbClr val="1B2A4A"/>
@@ -3520,6 +3539,7 @@
           <a:lstStyle xmlns:a="http://schemas.openxmlformats.org/drawingml/2006/main"/>
           <a:p xmlns:a="http://schemas.openxmlformats.org/drawingml/2006/main">
             <a:pPr algn="l">
+              <a:buNone/>
               <a:defRPr sz="1350" b="0">
                 <a:solidFill>
                   <a:srgbClr val="3F4A59"/>
@@ -3605,6 +3625,7 @@
           <a:lstStyle xmlns:a="http://schemas.openxmlformats.org/drawingml/2006/main"/>
           <a:p xmlns:a="http://schemas.openxmlformats.org/drawingml/2006/main">
             <a:pPr algn="l">
+              <a:buNone/>
               <a:defRPr sz="975" b="1">
                 <a:solidFill>
                   <a:srgbClr val="18A999"/>
@@ -3655,6 +3676,7 @@
           <a:lstStyle xmlns:a="http://schemas.openxmlformats.org/drawingml/2006/main"/>
           <a:p xmlns:a="http://schemas.openxmlformats.org/drawingml/2006/main">
             <a:pPr algn="l">
+              <a:buNone/>
               <a:defRPr sz="1500" b="1">
                 <a:solidFill>
                   <a:srgbClr val="18A999"/>
@@ -3705,6 +3727,7 @@
           <a:lstStyle xmlns:a="http://schemas.openxmlformats.org/drawingml/2006/main"/>
           <a:p xmlns:a="http://schemas.openxmlformats.org/drawingml/2006/main">
             <a:pPr algn="l">
+              <a:buNone/>
               <a:defRPr sz="1350" b="0">
                 <a:solidFill>
                   <a:srgbClr val="3F4A59"/>
@@ -3755,6 +3778,7 @@
           <a:lstStyle xmlns:a="http://schemas.openxmlformats.org/drawingml/2006/main"/>
           <a:p xmlns:a="http://schemas.openxmlformats.org/drawingml/2006/main">
             <a:pPr algn="ctr">
+              <a:buNone/>
               <a:defRPr sz="1725" b="1">
                 <a:solidFill>
                   <a:srgbClr val="1B2A4A"/>
@@ -3834,6 +3858,7 @@
           <a:lstStyle xmlns:a="http://schemas.openxmlformats.org/drawingml/2006/main"/>
           <a:p xmlns:a="http://schemas.openxmlformats.org/drawingml/2006/main">
             <a:pPr algn="r">
+              <a:buNone/>
               <a:defRPr sz="825" b="1">
                 <a:solidFill>
                   <a:srgbClr val="687386"/>
@@ -3884,6 +3909,7 @@
           <a:lstStyle xmlns:a="http://schemas.openxmlformats.org/drawingml/2006/main"/>
           <a:p xmlns:a="http://schemas.openxmlformats.org/drawingml/2006/main">
             <a:pPr algn="l">
+              <a:buNone/>
               <a:defRPr sz="900" b="1">
                 <a:solidFill>
                   <a:srgbClr val="C0562B"/>
@@ -3934,6 +3960,7 @@
           <a:lstStyle xmlns:a="http://schemas.openxmlformats.org/drawingml/2006/main"/>
           <a:p xmlns:a="http://schemas.openxmlformats.org/drawingml/2006/main">
             <a:pPr algn="l">
+              <a:buNone/>
               <a:defRPr sz="2850" b="1">
                 <a:solidFill>
                   <a:srgbClr val="1B2A4A"/>
@@ -3953,14 +3980,14 @@
       </p:sp>
       <p:pic>
         <p:nvPicPr>
-          <p:cNvPr id="9" name=""/>
+          <p:cNvPr id="10" name=""/>
           <p:cNvPicPr>
             <a:picLocks xmlns:a="http://schemas.openxmlformats.org/drawingml/2006/main" noChangeAspect="1"/>
           </p:cNvPicPr>
           <p:nvPr/>
         </p:nvPicPr>
         <p:blipFill>
-          <a:blip xmlns:r="http://schemas.openxmlformats.org/officeDocument/2006/relationships" xmlns:a="http://schemas.openxmlformats.org/drawingml/2006/main" r:embed="R43ec2c55db5443f4"/>
+          <a:blip xmlns:r="http://schemas.openxmlformats.org/officeDocument/2006/relationships" xmlns:a="http://schemas.openxmlformats.org/drawingml/2006/main" r:embed="Rf1086e60a198400a"/>
           <a:stretch xmlns:a="http://schemas.openxmlformats.org/drawingml/2006/main"/>
         </p:blipFill>
         <p:spPr>
@@ -4006,6 +4033,7 @@
           <a:lstStyle xmlns:a="http://schemas.openxmlformats.org/drawingml/2006/main"/>
           <a:p xmlns:a="http://schemas.openxmlformats.org/drawingml/2006/main">
             <a:pPr algn="l">
+              <a:buNone/>
               <a:defRPr sz="675" b="0">
                 <a:solidFill>
                   <a:srgbClr val="687386"/>
@@ -4085,6 +4113,7 @@
           <a:lstStyle xmlns:a="http://schemas.openxmlformats.org/drawingml/2006/main"/>
           <a:p xmlns:a="http://schemas.openxmlformats.org/drawingml/2006/main">
             <a:pPr algn="r">
+              <a:buNone/>
               <a:defRPr sz="825" b="1">
                 <a:solidFill>
                   <a:srgbClr val="B8C0CE"/>
@@ -4104,7 +4133,7 @@
       </p:sp>
       <p:sp>
         <p:nvSpPr>
-          <p:cNvPr id="2" name="loopbench-kicker">
+          <p:cNvPr id="2" name="measurement-kicker">
             <a:extLst xmlns:a="http://schemas.openxmlformats.org/drawingml/2006/main">
               <a:ext uri="{FF2B5EF4-FFF2-40B4-BE49-F238E27FC236}">
                 <a16:creationId xmlns:a16="http://schemas.microsoft.com/office/drawing/2014/main" id="{03E2CDA4-BAE6-4413-8FE2-610F621A5C3D}"/>
@@ -4135,6 +4164,7 @@
           <a:lstStyle xmlns:a="http://schemas.openxmlformats.org/drawingml/2006/main"/>
           <a:p xmlns:a="http://schemas.openxmlformats.org/drawingml/2006/main">
             <a:pPr algn="l">
+              <a:buNone/>
               <a:defRPr sz="900" b="1">
                 <a:solidFill>
                   <a:srgbClr val="18A999"/>
@@ -4147,14 +4177,14 @@
                   <a:srgbClr val="18A999"/>
                 </a:solidFill>
               </a:rPr>
-              <a:t>THE PORTABLE INSTRUMENT</a:t>
-            </a:r>
-          </a:p>
-        </p:txBody>
-      </p:sp>
-      <p:sp>
-        <p:nvSpPr>
-          <p:cNvPr id="3" name="loopbench-title">
+              <a:t>EMBEDDED MEASUREMENT</a:t>
+            </a:r>
+          </a:p>
+        </p:txBody>
+      </p:sp>
+      <p:sp>
+        <p:nvSpPr>
+          <p:cNvPr id="3" name="measurement-title">
             <a:extLst xmlns:a="http://schemas.openxmlformats.org/drawingml/2006/main">
               <a:ext uri="{FF2B5EF4-FFF2-40B4-BE49-F238E27FC236}">
                 <a16:creationId xmlns:a16="http://schemas.microsoft.com/office/drawing/2014/main" id="{6FA8AA7A-16DA-4706-BF47-E925653C8241}"/>
@@ -4185,6 +4215,7 @@
           <a:lstStyle xmlns:a="http://schemas.openxmlformats.org/drawingml/2006/main"/>
           <a:p xmlns:a="http://schemas.openxmlformats.org/drawingml/2006/main">
             <a:pPr algn="l">
+              <a:buNone/>
               <a:defRPr sz="2925" b="1">
                 <a:solidFill>
                   <a:srgbClr val="FFFFFF"/>
@@ -4197,11 +4228,12 @@
                   <a:srgbClr val="FFFFFF"/>
                 </a:solidFill>
               </a:rPr>
-              <a:t>loopbench turns measurement</a:t>
-            </a:r>
-          </a:p>
-          <a:p xmlns:a="http://schemas.openxmlformats.org/drawingml/2006/main">
-            <a:pPr algn="l">
+              <a:t>Every lab leaves</a:t>
+            </a:r>
+          </a:p>
+          <a:p xmlns:a="http://schemas.openxmlformats.org/drawingml/2006/main">
+            <a:pPr algn="l">
+              <a:buNone/>
               <a:defRPr sz="2925" b="1">
                 <a:solidFill>
                   <a:srgbClr val="FFFFFF"/>
@@ -4214,14 +4246,14 @@
                   <a:srgbClr val="FFFFFF"/>
                 </a:solidFill>
               </a:rPr>
-              <a:t>into a shared language</a:t>
-            </a:r>
-          </a:p>
-        </p:txBody>
-      </p:sp>
-      <p:sp>
-        <p:nvSpPr>
-          <p:cNvPr id="4" name="loopbench-body">
+              <a:t>an evidence trail</a:t>
+            </a:r>
+          </a:p>
+        </p:txBody>
+      </p:sp>
+      <p:sp>
+        <p:nvSpPr>
+          <p:cNvPr id="4" name="measurement-body">
             <a:extLst xmlns:a="http://schemas.openxmlformats.org/drawingml/2006/main">
               <a:ext uri="{FF2B5EF4-FFF2-40B4-BE49-F238E27FC236}">
                 <a16:creationId xmlns:a16="http://schemas.microsoft.com/office/drawing/2014/main" id="{C54DF35C-3DA7-413C-87B6-B80F0E8BC8FD}"/>
@@ -4252,6 +4284,7 @@
           <a:lstStyle xmlns:a="http://schemas.openxmlformats.org/drawingml/2006/main"/>
           <a:p xmlns:a="http://schemas.openxmlformats.org/drawingml/2006/main">
             <a:pPr algn="l">
+              <a:buNone/>
               <a:defRPr sz="1500" b="0">
                 <a:solidFill>
                   <a:srgbClr val="C5CDDA"/>
@@ -4264,7 +4297,7 @@
                   <a:srgbClr val="C5CDDA"/>
                 </a:solidFill>
               </a:rPr>
-              <a:t>Versioned protocols make the same claim testable across boards, robots, and future embodiments.</a:t>
+              <a:t>Reusable instrumentation belongs to the growing runtime. Every lab defines its events, records calibration, and reports uncertainty.</a:t>
             </a:r>
           </a:p>
         </p:txBody>
@@ -4337,6 +4370,7 @@
           <a:lstStyle xmlns:a="http://schemas.openxmlformats.org/drawingml/2006/main"/>
           <a:p xmlns:a="http://schemas.openxmlformats.org/drawingml/2006/main">
             <a:pPr algn="l">
+              <a:buNone/>
               <a:defRPr sz="1050" b="1">
                 <a:solidFill>
                   <a:srgbClr val="8FE2D8"/>
@@ -4349,7 +4383,7 @@
                   <a:srgbClr val="8FE2D8"/>
                 </a:solidFill>
               </a:rPr>
-              <a:t>loopbench / veto-latency</a:t>
+              <a:t>veto-latency / evidence record</a:t>
             </a:r>
           </a:p>
         </p:txBody>
@@ -4387,6 +4421,7 @@
           <a:lstStyle xmlns:a="http://schemas.openxmlformats.org/drawingml/2006/main"/>
           <a:p xmlns:a="http://schemas.openxmlformats.org/drawingml/2006/main">
             <a:pPr algn="l">
+              <a:buNone/>
               <a:defRPr sz="1275" b="0">
                 <a:solidFill>
                   <a:srgbClr val="E3E8F0"/>
@@ -4404,6 +4439,7 @@
           </a:p>
           <a:p xmlns:a="http://schemas.openxmlformats.org/drawingml/2006/main">
             <a:pPr algn="l">
+              <a:buNone/>
               <a:defRPr sz="1275" b="0">
                 <a:solidFill>
                   <a:srgbClr val="E3E8F0"/>
@@ -4426,6 +4462,7 @@
           </a:p>
           <a:p xmlns:a="http://schemas.openxmlformats.org/drawingml/2006/main">
             <a:pPr algn="l">
+              <a:buNone/>
               <a:defRPr sz="1275" b="0">
                 <a:solidFill>
                   <a:srgbClr val="E3E8F0"/>
@@ -4443,6 +4480,7 @@
           </a:p>
           <a:p xmlns:a="http://schemas.openxmlformats.org/drawingml/2006/main">
             <a:pPr algn="l">
+              <a:buNone/>
               <a:defRPr sz="1275" b="0">
                 <a:solidFill>
                   <a:srgbClr val="E3E8F0"/>
@@ -4465,6 +4503,7 @@
           </a:p>
           <a:p xmlns:a="http://schemas.openxmlformats.org/drawingml/2006/main">
             <a:pPr algn="l">
+              <a:buNone/>
               <a:defRPr sz="1275" b="0">
                 <a:solidFill>
                   <a:srgbClr val="E3E8F0"/>
@@ -4482,6 +4521,7 @@
           </a:p>
           <a:p xmlns:a="http://schemas.openxmlformats.org/drawingml/2006/main">
             <a:pPr algn="l">
+              <a:buNone/>
               <a:defRPr sz="1275" b="0">
                 <a:solidFill>
                   <a:srgbClr val="E3E8F0"/>
@@ -4504,6 +4544,7 @@
           </a:p>
           <a:p xmlns:a="http://schemas.openxmlformats.org/drawingml/2006/main">
             <a:pPr algn="l">
+              <a:buNone/>
               <a:defRPr sz="1275" b="0">
                 <a:solidFill>
                   <a:srgbClr val="E3E8F0"/>
@@ -4521,6 +4562,7 @@
           </a:p>
           <a:p xmlns:a="http://schemas.openxmlformats.org/drawingml/2006/main">
             <a:pPr algn="l">
+              <a:buNone/>
               <a:defRPr sz="1275" b="0">
                 <a:solidFill>
                   <a:srgbClr val="E3E8F0"/>
@@ -4538,6 +4580,7 @@
           </a:p>
           <a:p xmlns:a="http://schemas.openxmlformats.org/drawingml/2006/main">
             <a:pPr algn="l">
+              <a:buNone/>
               <a:defRPr sz="1275" b="0">
                 <a:solidFill>
                   <a:srgbClr val="E3E8F0"/>
@@ -4557,7 +4600,7 @@
       </p:sp>
       <p:sp>
         <p:nvSpPr>
-          <p:cNvPr id="8" name="loopbench-rule">
+          <p:cNvPr id="8" name="measurement-rule">
             <a:extLst xmlns:a="http://schemas.openxmlformats.org/drawingml/2006/main">
               <a:ext uri="{FF2B5EF4-FFF2-40B4-BE49-F238E27FC236}">
                 <a16:creationId xmlns:a16="http://schemas.microsoft.com/office/drawing/2014/main" id="{23EF5E9F-ECCF-4FEC-B779-9A08C99E8808}"/>
@@ -4588,7 +4631,7 @@
       </p:sp>
       <p:sp>
         <p:nvSpPr>
-          <p:cNvPr id="9" name="loopbench-claim">
+          <p:cNvPr id="9" name="measurement-claim">
             <a:extLst xmlns:a="http://schemas.openxmlformats.org/drawingml/2006/main">
               <a:ext uri="{FF2B5EF4-FFF2-40B4-BE49-F238E27FC236}">
                 <a16:creationId xmlns:a16="http://schemas.microsoft.com/office/drawing/2014/main" id="{E729F98A-8C9A-4AAE-B950-6FA44FE10B9F}"/>
@@ -4619,6 +4662,7 @@
           <a:lstStyle xmlns:a="http://schemas.openxmlformats.org/drawingml/2006/main"/>
           <a:p xmlns:a="http://schemas.openxmlformats.org/drawingml/2006/main">
             <a:pPr algn="l">
+              <a:buNone/>
               <a:defRPr sz="1875" b="1">
                 <a:solidFill>
                   <a:srgbClr val="FFFFFF"/>
@@ -4631,11 +4675,12 @@
                   <a:srgbClr val="FFFFFF"/>
                 </a:solidFill>
               </a:rPr>
-              <a:t>The software is a coequal product,</a:t>
-            </a:r>
-          </a:p>
-          <a:p xmlns:a="http://schemas.openxmlformats.org/drawingml/2006/main">
-            <a:pPr algn="l">
+              <a:t>The harness serves the reference system,</a:t>
+            </a:r>
+          </a:p>
+          <a:p xmlns:a="http://schemas.openxmlformats.org/drawingml/2006/main">
+            <a:pPr algn="l">
+              <a:buNone/>
               <a:defRPr sz="1875" b="1">
                 <a:solidFill>
                   <a:srgbClr val="FFFFFF"/>
@@ -4648,7 +4693,7 @@
                   <a:srgbClr val="FFFFFF"/>
                 </a:solidFill>
               </a:rPr>
-              <a:t>not an appendix script.</a:t>
+              <a:t>not a separate software product.</a:t>
             </a:r>
           </a:p>
         </p:txBody>
@@ -4715,6 +4760,7 @@
           <a:lstStyle xmlns:a="http://schemas.openxmlformats.org/drawingml/2006/main"/>
           <a:p xmlns:a="http://schemas.openxmlformats.org/drawingml/2006/main">
             <a:pPr algn="r">
+              <a:buNone/>
               <a:defRPr sz="825" b="1">
                 <a:solidFill>
                   <a:srgbClr val="687386"/>
@@ -4765,6 +4811,7 @@
           <a:lstStyle xmlns:a="http://schemas.openxmlformats.org/drawingml/2006/main"/>
           <a:p xmlns:a="http://schemas.openxmlformats.org/drawingml/2006/main">
             <a:pPr algn="l">
+              <a:buNone/>
               <a:defRPr sz="900" b="1">
                 <a:solidFill>
                   <a:srgbClr val="18A999"/>
@@ -4815,6 +4862,7 @@
           <a:lstStyle xmlns:a="http://schemas.openxmlformats.org/drawingml/2006/main"/>
           <a:p xmlns:a="http://schemas.openxmlformats.org/drawingml/2006/main">
             <a:pPr algn="l">
+              <a:buNone/>
               <a:defRPr sz="2850" b="1">
                 <a:solidFill>
                   <a:srgbClr val="1B2A4A"/>
@@ -4865,6 +4913,7 @@
           <a:lstStyle xmlns:a="http://schemas.openxmlformats.org/drawingml/2006/main"/>
           <a:p xmlns:a="http://schemas.openxmlformats.org/drawingml/2006/main">
             <a:pPr algn="l">
+              <a:buNone/>
               <a:defRPr sz="1425" b="0">
                 <a:solidFill>
                   <a:srgbClr val="687386"/>
@@ -4915,6 +4964,7 @@
           <a:lstStyle xmlns:a="http://schemas.openxmlformats.org/drawingml/2006/main"/>
           <a:p xmlns:a="http://schemas.openxmlformats.org/drawingml/2006/main">
             <a:pPr algn="l">
+              <a:buNone/>
               <a:defRPr sz="975" b="1">
                 <a:solidFill>
                   <a:srgbClr val="C0562B"/>
@@ -4965,6 +5015,7 @@
           <a:lstStyle xmlns:a="http://schemas.openxmlformats.org/drawingml/2006/main"/>
           <a:p xmlns:a="http://schemas.openxmlformats.org/drawingml/2006/main">
             <a:pPr algn="l">
+              <a:buNone/>
               <a:defRPr sz="1425" b="1">
                 <a:solidFill>
                   <a:srgbClr val="1B2A4A"/>
@@ -5015,6 +5066,7 @@
           <a:lstStyle xmlns:a="http://schemas.openxmlformats.org/drawingml/2006/main"/>
           <a:p xmlns:a="http://schemas.openxmlformats.org/drawingml/2006/main">
             <a:pPr algn="l">
+              <a:buNone/>
               <a:defRPr sz="1350" b="0">
                 <a:solidFill>
                   <a:srgbClr val="3F4A59"/>
@@ -5096,6 +5148,7 @@
           <a:lstStyle xmlns:a="http://schemas.openxmlformats.org/drawingml/2006/main"/>
           <a:p xmlns:a="http://schemas.openxmlformats.org/drawingml/2006/main">
             <a:pPr algn="l">
+              <a:buNone/>
               <a:defRPr sz="975" b="1">
                 <a:solidFill>
                   <a:srgbClr val="18A999"/>
@@ -5146,6 +5199,7 @@
           <a:lstStyle xmlns:a="http://schemas.openxmlformats.org/drawingml/2006/main"/>
           <a:p xmlns:a="http://schemas.openxmlformats.org/drawingml/2006/main">
             <a:pPr algn="l">
+              <a:buNone/>
               <a:defRPr sz="1425" b="1">
                 <a:solidFill>
                   <a:srgbClr val="1B2A4A"/>
@@ -5196,6 +5250,7 @@
           <a:lstStyle xmlns:a="http://schemas.openxmlformats.org/drawingml/2006/main"/>
           <a:p xmlns:a="http://schemas.openxmlformats.org/drawingml/2006/main">
             <a:pPr algn="l">
+              <a:buNone/>
               <a:defRPr sz="1350" b="0">
                 <a:solidFill>
                   <a:srgbClr val="3F4A59"/>
@@ -5277,6 +5332,7 @@
           <a:lstStyle xmlns:a="http://schemas.openxmlformats.org/drawingml/2006/main"/>
           <a:p xmlns:a="http://schemas.openxmlformats.org/drawingml/2006/main">
             <a:pPr algn="l">
+              <a:buNone/>
               <a:defRPr sz="975" b="1">
                 <a:solidFill>
                   <a:srgbClr val="C0562B"/>
@@ -5327,6 +5383,7 @@
           <a:lstStyle xmlns:a="http://schemas.openxmlformats.org/drawingml/2006/main"/>
           <a:p xmlns:a="http://schemas.openxmlformats.org/drawingml/2006/main">
             <a:pPr algn="l">
+              <a:buNone/>
               <a:defRPr sz="1425" b="1">
                 <a:solidFill>
                   <a:srgbClr val="1B2A4A"/>
@@ -5377,6 +5434,7 @@
           <a:lstStyle xmlns:a="http://schemas.openxmlformats.org/drawingml/2006/main"/>
           <a:p xmlns:a="http://schemas.openxmlformats.org/drawingml/2006/main">
             <a:pPr algn="l">
+              <a:buNone/>
               <a:defRPr sz="1350" b="0">
                 <a:solidFill>
                   <a:srgbClr val="3F4A59"/>
@@ -5458,6 +5516,7 @@
           <a:lstStyle xmlns:a="http://schemas.openxmlformats.org/drawingml/2006/main"/>
           <a:p xmlns:a="http://schemas.openxmlformats.org/drawingml/2006/main">
             <a:pPr algn="l">
+              <a:buNone/>
               <a:defRPr sz="975" b="1">
                 <a:solidFill>
                   <a:srgbClr val="C0562B"/>
@@ -5508,6 +5567,7 @@
           <a:lstStyle xmlns:a="http://schemas.openxmlformats.org/drawingml/2006/main"/>
           <a:p xmlns:a="http://schemas.openxmlformats.org/drawingml/2006/main">
             <a:pPr algn="l">
+              <a:buNone/>
               <a:defRPr sz="1425" b="1">
                 <a:solidFill>
                   <a:srgbClr val="1B2A4A"/>
@@ -5558,6 +5618,7 @@
           <a:lstStyle xmlns:a="http://schemas.openxmlformats.org/drawingml/2006/main"/>
           <a:p xmlns:a="http://schemas.openxmlformats.org/drawingml/2006/main">
             <a:pPr algn="l">
+              <a:buNone/>
               <a:defRPr sz="1350" b="0">
                 <a:solidFill>
                   <a:srgbClr val="3F4A59"/>
@@ -5637,6 +5698,7 @@
           <a:lstStyle xmlns:a="http://schemas.openxmlformats.org/drawingml/2006/main"/>
           <a:p xmlns:a="http://schemas.openxmlformats.org/drawingml/2006/main">
             <a:pPr algn="r">
+              <a:buNone/>
               <a:defRPr sz="825" b="1">
                 <a:solidFill>
                   <a:srgbClr val="687386"/>
@@ -5687,6 +5749,7 @@
           <a:lstStyle xmlns:a="http://schemas.openxmlformats.org/drawingml/2006/main"/>
           <a:p xmlns:a="http://schemas.openxmlformats.org/drawingml/2006/main">
             <a:pPr algn="l">
+              <a:buNone/>
               <a:defRPr sz="900" b="1">
                 <a:solidFill>
                   <a:srgbClr val="18A999"/>
@@ -5737,6 +5800,7 @@
           <a:lstStyle xmlns:a="http://schemas.openxmlformats.org/drawingml/2006/main"/>
           <a:p xmlns:a="http://schemas.openxmlformats.org/drawingml/2006/main">
             <a:pPr algn="l">
+              <a:buNone/>
               <a:defRPr sz="2850" b="1">
                 <a:solidFill>
                   <a:srgbClr val="1B2A4A"/>
@@ -5787,6 +5851,7 @@
           <a:lstStyle xmlns:a="http://schemas.openxmlformats.org/drawingml/2006/main"/>
           <a:p xmlns:a="http://schemas.openxmlformats.org/drawingml/2006/main">
             <a:pPr algn="l">
+              <a:buNone/>
               <a:defRPr sz="1425" b="0">
                 <a:solidFill>
                   <a:srgbClr val="687386"/>
@@ -5872,6 +5937,7 @@
           <a:lstStyle xmlns:a="http://schemas.openxmlformats.org/drawingml/2006/main"/>
           <a:p xmlns:a="http://schemas.openxmlformats.org/drawingml/2006/main">
             <a:pPr algn="l">
+              <a:buNone/>
               <a:defRPr sz="1275" b="1">
                 <a:solidFill>
                   <a:srgbClr val="1B2A4A"/>
@@ -5922,6 +5988,7 @@
           <a:lstStyle xmlns:a="http://schemas.openxmlformats.org/drawingml/2006/main"/>
           <a:p xmlns:a="http://schemas.openxmlformats.org/drawingml/2006/main">
             <a:pPr algn="l">
+              <a:buNone/>
               <a:defRPr sz="1500" b="1">
                 <a:solidFill>
                   <a:srgbClr val="1B2A4A"/>
@@ -5972,6 +6039,7 @@
           <a:lstStyle xmlns:a="http://schemas.openxmlformats.org/drawingml/2006/main"/>
           <a:p xmlns:a="http://schemas.openxmlformats.org/drawingml/2006/main">
             <a:pPr algn="l">
+              <a:buNone/>
               <a:defRPr sz="825" b="1">
                 <a:solidFill>
                   <a:srgbClr val="687386"/>
@@ -6057,6 +6125,7 @@
           <a:lstStyle xmlns:a="http://schemas.openxmlformats.org/drawingml/2006/main"/>
           <a:p xmlns:a="http://schemas.openxmlformats.org/drawingml/2006/main">
             <a:pPr algn="l">
+              <a:buNone/>
               <a:defRPr sz="1275" b="1">
                 <a:solidFill>
                   <a:srgbClr val="18A999"/>
@@ -6107,6 +6176,7 @@
           <a:lstStyle xmlns:a="http://schemas.openxmlformats.org/drawingml/2006/main"/>
           <a:p xmlns:a="http://schemas.openxmlformats.org/drawingml/2006/main">
             <a:pPr algn="l">
+              <a:buNone/>
               <a:defRPr sz="1500" b="1">
                 <a:solidFill>
                   <a:srgbClr val="1B2A4A"/>
@@ -6157,6 +6227,7 @@
           <a:lstStyle xmlns:a="http://schemas.openxmlformats.org/drawingml/2006/main"/>
           <a:p xmlns:a="http://schemas.openxmlformats.org/drawingml/2006/main">
             <a:pPr algn="l">
+              <a:buNone/>
               <a:defRPr sz="825" b="1">
                 <a:solidFill>
                   <a:srgbClr val="687386"/>
@@ -6242,6 +6313,7 @@
           <a:lstStyle xmlns:a="http://schemas.openxmlformats.org/drawingml/2006/main"/>
           <a:p xmlns:a="http://schemas.openxmlformats.org/drawingml/2006/main">
             <a:pPr algn="l">
+              <a:buNone/>
               <a:defRPr sz="1275" b="1">
                 <a:solidFill>
                   <a:srgbClr val="C0562B"/>
@@ -6292,6 +6364,7 @@
           <a:lstStyle xmlns:a="http://schemas.openxmlformats.org/drawingml/2006/main"/>
           <a:p xmlns:a="http://schemas.openxmlformats.org/drawingml/2006/main">
             <a:pPr algn="l">
+              <a:buNone/>
               <a:defRPr sz="1500" b="1">
                 <a:solidFill>
                   <a:srgbClr val="1B2A4A"/>
@@ -6342,6 +6415,7 @@
           <a:lstStyle xmlns:a="http://schemas.openxmlformats.org/drawingml/2006/main"/>
           <a:p xmlns:a="http://schemas.openxmlformats.org/drawingml/2006/main">
             <a:pPr algn="l">
+              <a:buNone/>
               <a:defRPr sz="825" b="1">
                 <a:solidFill>
                   <a:srgbClr val="687386"/>
@@ -6427,6 +6501,7 @@
           <a:lstStyle xmlns:a="http://schemas.openxmlformats.org/drawingml/2006/main"/>
           <a:p xmlns:a="http://schemas.openxmlformats.org/drawingml/2006/main">
             <a:pPr algn="l">
+              <a:buNone/>
               <a:defRPr sz="1275" b="1">
                 <a:solidFill>
                   <a:srgbClr val="D98C1F"/>
@@ -6477,6 +6552,7 @@
           <a:lstStyle xmlns:a="http://schemas.openxmlformats.org/drawingml/2006/main"/>
           <a:p xmlns:a="http://schemas.openxmlformats.org/drawingml/2006/main">
             <a:pPr algn="l">
+              <a:buNone/>
               <a:defRPr sz="1500" b="1">
                 <a:solidFill>
                   <a:srgbClr val="1B2A4A"/>
@@ -6527,6 +6603,7 @@
           <a:lstStyle xmlns:a="http://schemas.openxmlformats.org/drawingml/2006/main"/>
           <a:p xmlns:a="http://schemas.openxmlformats.org/drawingml/2006/main">
             <a:pPr algn="l">
+              <a:buNone/>
               <a:defRPr sz="825" b="1">
                 <a:solidFill>
                   <a:srgbClr val="687386"/>
@@ -6577,6 +6654,7 @@
           <a:lstStyle xmlns:a="http://schemas.openxmlformats.org/drawingml/2006/main"/>
           <a:p xmlns:a="http://schemas.openxmlformats.org/drawingml/2006/main">
             <a:pPr algn="ctr">
+              <a:buNone/>
               <a:defRPr sz="1425" b="1">
                 <a:solidFill>
                   <a:srgbClr val="3F4A59"/>
@@ -6656,6 +6734,7 @@
           <a:lstStyle xmlns:a="http://schemas.openxmlformats.org/drawingml/2006/main"/>
           <a:p xmlns:a="http://schemas.openxmlformats.org/drawingml/2006/main">
             <a:pPr algn="r">
+              <a:buNone/>
               <a:defRPr sz="825" b="1">
                 <a:solidFill>
                   <a:srgbClr val="687386"/>
@@ -6706,6 +6785,7 @@
           <a:lstStyle xmlns:a="http://schemas.openxmlformats.org/drawingml/2006/main"/>
           <a:p xmlns:a="http://schemas.openxmlformats.org/drawingml/2006/main">
             <a:pPr algn="l">
+              <a:buNone/>
               <a:defRPr sz="900" b="1">
                 <a:solidFill>
                   <a:srgbClr val="18A999"/>
@@ -6756,6 +6836,7 @@
           <a:lstStyle xmlns:a="http://schemas.openxmlformats.org/drawingml/2006/main"/>
           <a:p xmlns:a="http://schemas.openxmlformats.org/drawingml/2006/main">
             <a:pPr algn="l">
+              <a:buNone/>
               <a:defRPr sz="3150" b="1">
                 <a:solidFill>
                   <a:srgbClr val="1B2A4A"/>
@@ -6773,6 +6854,7 @@
           </a:p>
           <a:p xmlns:a="http://schemas.openxmlformats.org/drawingml/2006/main">
             <a:pPr algn="l">
+              <a:buNone/>
               <a:defRPr sz="3150" b="1">
                 <a:solidFill>
                   <a:srgbClr val="1B2A4A"/>
@@ -6854,6 +6936,7 @@
           <a:lstStyle xmlns:a="http://schemas.openxmlformats.org/drawingml/2006/main"/>
           <a:p xmlns:a="http://schemas.openxmlformats.org/drawingml/2006/main">
             <a:pPr algn="l">
+              <a:buNone/>
               <a:defRPr sz="1500" b="1">
                 <a:solidFill>
                   <a:srgbClr val="1B2A4A"/>
@@ -6904,6 +6987,7 @@
           <a:lstStyle xmlns:a="http://schemas.openxmlformats.org/drawingml/2006/main"/>
           <a:p xmlns:a="http://schemas.openxmlformats.org/drawingml/2006/main">
             <a:pPr algn="l">
+              <a:buNone/>
               <a:defRPr sz="1350" b="0">
                 <a:solidFill>
                   <a:srgbClr val="3F4A59"/>
@@ -6954,6 +7038,7 @@
           <a:lstStyle xmlns:a="http://schemas.openxmlformats.org/drawingml/2006/main"/>
           <a:p xmlns:a="http://schemas.openxmlformats.org/drawingml/2006/main">
             <a:pPr algn="l">
+              <a:buNone/>
               <a:defRPr sz="1500" b="1">
                 <a:solidFill>
                   <a:srgbClr val="1B2A4A"/>
@@ -7004,6 +7089,7 @@
           <a:lstStyle xmlns:a="http://schemas.openxmlformats.org/drawingml/2006/main"/>
           <a:p xmlns:a="http://schemas.openxmlformats.org/drawingml/2006/main">
             <a:pPr algn="l">
+              <a:buNone/>
               <a:defRPr sz="1350" b="0">
                 <a:solidFill>
                   <a:srgbClr val="3F4A59"/>
@@ -7054,6 +7140,7 @@
           <a:lstStyle xmlns:a="http://schemas.openxmlformats.org/drawingml/2006/main"/>
           <a:p xmlns:a="http://schemas.openxmlformats.org/drawingml/2006/main">
             <a:pPr algn="l">
+              <a:buNone/>
               <a:defRPr sz="1500" b="1">
                 <a:solidFill>
                   <a:srgbClr val="1B2A4A"/>
@@ -7104,6 +7191,7 @@
           <a:lstStyle xmlns:a="http://schemas.openxmlformats.org/drawingml/2006/main"/>
           <a:p xmlns:a="http://schemas.openxmlformats.org/drawingml/2006/main">
             <a:pPr algn="l">
+              <a:buNone/>
               <a:defRPr sz="1350" b="0">
                 <a:solidFill>
                   <a:srgbClr val="3F4A59"/>
@@ -7187,6 +7275,7 @@
           <a:lstStyle xmlns:a="http://schemas.openxmlformats.org/drawingml/2006/main"/>
           <a:p xmlns:a="http://schemas.openxmlformats.org/drawingml/2006/main">
             <a:pPr algn="ctr">
+              <a:buNone/>
               <a:defRPr sz="1350" b="1">
                 <a:solidFill>
                   <a:srgbClr val="18A999"/>
@@ -7266,6 +7355,7 @@
           <a:lstStyle xmlns:a="http://schemas.openxmlformats.org/drawingml/2006/main"/>
           <a:p xmlns:a="http://schemas.openxmlformats.org/drawingml/2006/main">
             <a:pPr algn="r">
+              <a:buNone/>
               <a:defRPr sz="825" b="1">
                 <a:solidFill>
                   <a:srgbClr val="B8C0CE"/>
@@ -7316,6 +7406,7 @@
           <a:lstStyle xmlns:a="http://schemas.openxmlformats.org/drawingml/2006/main"/>
           <a:p xmlns:a="http://schemas.openxmlformats.org/drawingml/2006/main">
             <a:pPr algn="l">
+              <a:buNone/>
               <a:defRPr sz="900" b="1">
                 <a:solidFill>
                   <a:srgbClr val="F4C08B"/>
@@ -7366,6 +7457,7 @@
           <a:lstStyle xmlns:a="http://schemas.openxmlformats.org/drawingml/2006/main"/>
           <a:p xmlns:a="http://schemas.openxmlformats.org/drawingml/2006/main">
             <a:pPr algn="l">
+              <a:buNone/>
               <a:defRPr sz="3075" b="1">
                 <a:solidFill>
                   <a:srgbClr val="FFFFFF"/>
@@ -7383,6 +7475,7 @@
           </a:p>
           <a:p xmlns:a="http://schemas.openxmlformats.org/drawingml/2006/main">
             <a:pPr algn="l">
+              <a:buNone/>
               <a:defRPr sz="3075" b="1">
                 <a:solidFill>
                   <a:srgbClr val="FFFFFF"/>
@@ -7466,6 +7559,7 @@
           <a:lstStyle xmlns:a="http://schemas.openxmlformats.org/drawingml/2006/main"/>
           <a:p xmlns:a="http://schemas.openxmlformats.org/drawingml/2006/main">
             <a:pPr algn="l">
+              <a:buNone/>
               <a:defRPr sz="975" b="1">
                 <a:solidFill>
                   <a:srgbClr val="C0562B"/>
@@ -7516,6 +7610,7 @@
           <a:lstStyle xmlns:a="http://schemas.openxmlformats.org/drawingml/2006/main"/>
           <a:p xmlns:a="http://schemas.openxmlformats.org/drawingml/2006/main">
             <a:pPr algn="l">
+              <a:buNone/>
               <a:defRPr sz="2850" b="1">
                 <a:solidFill>
                   <a:srgbClr val="1B2A4A"/>
@@ -7566,6 +7661,7 @@
           <a:lstStyle xmlns:a="http://schemas.openxmlformats.org/drawingml/2006/main"/>
           <a:p xmlns:a="http://schemas.openxmlformats.org/drawingml/2006/main">
             <a:pPr algn="l">
+              <a:buNone/>
               <a:defRPr sz="1350" b="0">
                 <a:solidFill>
                   <a:srgbClr val="3F4A59"/>
@@ -7583,6 +7679,7 @@
           </a:p>
           <a:p xmlns:a="http://schemas.openxmlformats.org/drawingml/2006/main">
             <a:pPr algn="l">
+              <a:buNone/>
               <a:defRPr sz="1350" b="0">
                 <a:solidFill>
                   <a:srgbClr val="3F4A59"/>
@@ -7633,6 +7730,7 @@
           <a:lstStyle xmlns:a="http://schemas.openxmlformats.org/drawingml/2006/main"/>
           <a:p xmlns:a="http://schemas.openxmlformats.org/drawingml/2006/main">
             <a:pPr algn="l">
+              <a:buNone/>
               <a:defRPr sz="900" b="1">
                 <a:solidFill>
                   <a:srgbClr val="F4C08B"/>
@@ -7683,6 +7781,7 @@
           <a:lstStyle xmlns:a="http://schemas.openxmlformats.org/drawingml/2006/main"/>
           <a:p xmlns:a="http://schemas.openxmlformats.org/drawingml/2006/main">
             <a:pPr algn="l">
+              <a:buNone/>
               <a:defRPr sz="1500" b="1">
                 <a:solidFill>
                   <a:srgbClr val="D7DEE8"/>
@@ -7733,6 +7832,7 @@
           <a:lstStyle xmlns:a="http://schemas.openxmlformats.org/drawingml/2006/main"/>
           <a:p xmlns:a="http://schemas.openxmlformats.org/drawingml/2006/main">
             <a:pPr algn="l">
+              <a:buNone/>
               <a:defRPr sz="900" b="1">
                 <a:solidFill>
                   <a:srgbClr val="F4C08B"/>
@@ -7783,6 +7883,7 @@
           <a:lstStyle xmlns:a="http://schemas.openxmlformats.org/drawingml/2006/main"/>
           <a:p xmlns:a="http://schemas.openxmlformats.org/drawingml/2006/main">
             <a:pPr algn="l">
+              <a:buNone/>
               <a:defRPr sz="1500" b="0">
                 <a:solidFill>
                   <a:srgbClr val="D7DEE8"/>
@@ -7833,6 +7934,7 @@
           <a:lstStyle xmlns:a="http://schemas.openxmlformats.org/drawingml/2006/main"/>
           <a:p xmlns:a="http://schemas.openxmlformats.org/drawingml/2006/main">
             <a:pPr algn="l">
+              <a:buNone/>
               <a:defRPr sz="900" b="1">
                 <a:solidFill>
                   <a:srgbClr val="F4C08B"/>
@@ -7883,6 +7985,7 @@
           <a:lstStyle xmlns:a="http://schemas.openxmlformats.org/drawingml/2006/main"/>
           <a:p xmlns:a="http://schemas.openxmlformats.org/drawingml/2006/main">
             <a:pPr algn="l">
+              <a:buNone/>
               <a:defRPr sz="1500" b="0">
                 <a:solidFill>
                   <a:srgbClr val="D7DEE8"/>
@@ -7933,6 +8036,7 @@
           <a:lstStyle xmlns:a="http://schemas.openxmlformats.org/drawingml/2006/main"/>
           <a:p xmlns:a="http://schemas.openxmlformats.org/drawingml/2006/main">
             <a:pPr algn="l">
+              <a:buNone/>
               <a:defRPr sz="675" b="0">
                 <a:solidFill>
                   <a:srgbClr val="687386"/>
@@ -8012,6 +8116,7 @@
           <a:lstStyle xmlns:a="http://schemas.openxmlformats.org/drawingml/2006/main"/>
           <a:p xmlns:a="http://schemas.openxmlformats.org/drawingml/2006/main">
             <a:pPr algn="r">
+              <a:buNone/>
               <a:defRPr sz="825" b="1">
                 <a:solidFill>
                   <a:srgbClr val="687386"/>
@@ -8062,6 +8167,7 @@
           <a:lstStyle xmlns:a="http://schemas.openxmlformats.org/drawingml/2006/main"/>
           <a:p xmlns:a="http://schemas.openxmlformats.org/drawingml/2006/main">
             <a:pPr algn="l">
+              <a:buNone/>
               <a:defRPr sz="900" b="1">
                 <a:solidFill>
                   <a:srgbClr val="18A999"/>
@@ -8112,6 +8218,7 @@
           <a:lstStyle xmlns:a="http://schemas.openxmlformats.org/drawingml/2006/main"/>
           <a:p xmlns:a="http://schemas.openxmlformats.org/drawingml/2006/main">
             <a:pPr algn="l">
+              <a:buNone/>
               <a:defRPr sz="2850" b="1">
                 <a:solidFill>
                   <a:srgbClr val="1B2A4A"/>
@@ -8162,6 +8269,7 @@
           <a:lstStyle xmlns:a="http://schemas.openxmlformats.org/drawingml/2006/main"/>
           <a:p xmlns:a="http://schemas.openxmlformats.org/drawingml/2006/main">
             <a:pPr algn="l">
+              <a:buNone/>
               <a:defRPr sz="1425" b="0">
                 <a:solidFill>
                   <a:srgbClr val="687386"/>
@@ -8243,6 +8351,7 @@
           <a:lstStyle xmlns:a="http://schemas.openxmlformats.org/drawingml/2006/main"/>
           <a:p xmlns:a="http://schemas.openxmlformats.org/drawingml/2006/main">
             <a:pPr algn="l">
+              <a:buNone/>
               <a:defRPr sz="1125" b="1">
                 <a:solidFill>
                   <a:srgbClr val="18A999"/>
@@ -8293,6 +8402,7 @@
           <a:lstStyle xmlns:a="http://schemas.openxmlformats.org/drawingml/2006/main"/>
           <a:p xmlns:a="http://schemas.openxmlformats.org/drawingml/2006/main">
             <a:pPr algn="l">
+              <a:buNone/>
               <a:defRPr sz="1500" b="1">
                 <a:solidFill>
                   <a:srgbClr val="1B2A4A"/>
@@ -8315,6 +8425,7 @@
           </a:p>
           <a:p xmlns:a="http://schemas.openxmlformats.org/drawingml/2006/main">
             <a:pPr algn="l">
+              <a:buNone/>
               <a:defRPr sz="1500" b="1">
                 <a:solidFill>
                   <a:srgbClr val="1B2A4A"/>
@@ -8337,6 +8448,7 @@
           </a:p>
           <a:p xmlns:a="http://schemas.openxmlformats.org/drawingml/2006/main">
             <a:pPr algn="l">
+              <a:buNone/>
               <a:defRPr sz="1500" b="1">
                 <a:solidFill>
                   <a:srgbClr val="1B2A4A"/>
@@ -8359,6 +8471,7 @@
           </a:p>
           <a:p xmlns:a="http://schemas.openxmlformats.org/drawingml/2006/main">
             <a:pPr algn="l">
+              <a:buNone/>
               <a:defRPr sz="1500" b="1">
                 <a:solidFill>
                   <a:srgbClr val="1B2A4A"/>
@@ -8371,7 +8484,7 @@
                   <a:srgbClr val="1B2A4A"/>
                 </a:solidFill>
               </a:rPr>
-              <a:t>loopbench protocol and software</a:t>
+              <a:t>Embedded measurement and evidence records</a:t>
             </a:r>
           </a:p>
           <a:p xmlns:a="http://schemas.openxmlformats.org/drawingml/2006/main">
@@ -8381,6 +8494,7 @@
           </a:p>
           <a:p xmlns:a="http://schemas.openxmlformats.org/drawingml/2006/main">
             <a:pPr algn="l">
+              <a:buNone/>
               <a:defRPr sz="1500" b="1">
                 <a:solidFill>
                   <a:srgbClr val="1B2A4A"/>
@@ -8431,6 +8545,7 @@
           <a:lstStyle xmlns:a="http://schemas.openxmlformats.org/drawingml/2006/main"/>
           <a:p xmlns:a="http://schemas.openxmlformats.org/drawingml/2006/main">
             <a:pPr algn="l">
+              <a:buNone/>
               <a:defRPr sz="1125" b="1">
                 <a:solidFill>
                   <a:srgbClr val="C0562B"/>
@@ -8481,6 +8596,7 @@
           <a:lstStyle xmlns:a="http://schemas.openxmlformats.org/drawingml/2006/main"/>
           <a:p xmlns:a="http://schemas.openxmlformats.org/drawingml/2006/main">
             <a:pPr algn="l">
+              <a:buNone/>
               <a:defRPr sz="1500" b="1">
                 <a:solidFill>
                   <a:srgbClr val="1B2A4A"/>
@@ -8503,6 +8619,7 @@
           </a:p>
           <a:p xmlns:a="http://schemas.openxmlformats.org/drawingml/2006/main">
             <a:pPr algn="l">
+              <a:buNone/>
               <a:defRPr sz="1500" b="1">
                 <a:solidFill>
                   <a:srgbClr val="1B2A4A"/>
@@ -8525,6 +8642,7 @@
           </a:p>
           <a:p xmlns:a="http://schemas.openxmlformats.org/drawingml/2006/main">
             <a:pPr algn="l">
+              <a:buNone/>
               <a:defRPr sz="1500" b="1">
                 <a:solidFill>
                   <a:srgbClr val="1B2A4A"/>
@@ -8547,6 +8665,7 @@
           </a:p>
           <a:p xmlns:a="http://schemas.openxmlformats.org/drawingml/2006/main">
             <a:pPr algn="l">
+              <a:buNone/>
               <a:defRPr sz="1500" b="1">
                 <a:solidFill>
                   <a:srgbClr val="1B2A4A"/>
@@ -8569,6 +8688,7 @@
           </a:p>
           <a:p xmlns:a="http://schemas.openxmlformats.org/drawingml/2006/main">
             <a:pPr algn="l">
+              <a:buNone/>
               <a:defRPr sz="1500" b="1">
                 <a:solidFill>
                   <a:srgbClr val="1B2A4A"/>
@@ -8652,6 +8772,7 @@
           <a:lstStyle xmlns:a="http://schemas.openxmlformats.org/drawingml/2006/main"/>
           <a:p xmlns:a="http://schemas.openxmlformats.org/drawingml/2006/main">
             <a:pPr algn="ctr">
+              <a:buNone/>
               <a:defRPr sz="1275" b="1">
                 <a:solidFill>
                   <a:srgbClr val="1B2A4A"/>
@@ -8731,6 +8852,7 @@
           <a:lstStyle xmlns:a="http://schemas.openxmlformats.org/drawingml/2006/main"/>
           <a:p xmlns:a="http://schemas.openxmlformats.org/drawingml/2006/main">
             <a:pPr algn="l">
+              <a:buNone/>
               <a:defRPr sz="900" b="1">
                 <a:solidFill>
                   <a:srgbClr val="18A999"/>
@@ -8781,6 +8903,7 @@
           <a:lstStyle xmlns:a="http://schemas.openxmlformats.org/drawingml/2006/main"/>
           <a:p xmlns:a="http://schemas.openxmlformats.org/drawingml/2006/main">
             <a:pPr algn="l">
+              <a:buNone/>
               <a:defRPr sz="3900" b="1">
                 <a:solidFill>
                   <a:srgbClr val="FFFFFF"/>
@@ -8798,6 +8921,7 @@
           </a:p>
           <a:p xmlns:a="http://schemas.openxmlformats.org/drawingml/2006/main">
             <a:pPr algn="l">
+              <a:buNone/>
               <a:defRPr sz="3900" b="1">
                 <a:solidFill>
                   <a:srgbClr val="FFFFFF"/>
@@ -8848,6 +8972,7 @@
           <a:lstStyle xmlns:a="http://schemas.openxmlformats.org/drawingml/2006/main"/>
           <a:p xmlns:a="http://schemas.openxmlformats.org/drawingml/2006/main">
             <a:pPr algn="l">
+              <a:buNone/>
               <a:defRPr sz="1725" b="0">
                 <a:solidFill>
                   <a:srgbClr val="D2D9E4"/>
@@ -8929,6 +9054,7 @@
           <a:lstStyle xmlns:a="http://schemas.openxmlformats.org/drawingml/2006/main"/>
           <a:p xmlns:a="http://schemas.openxmlformats.org/drawingml/2006/main">
             <a:pPr algn="l">
+              <a:buNone/>
               <a:defRPr sz="900" b="1">
                 <a:solidFill>
                   <a:srgbClr val="C0562B"/>
@@ -8979,6 +9105,7 @@
           <a:lstStyle xmlns:a="http://schemas.openxmlformats.org/drawingml/2006/main"/>
           <a:p xmlns:a="http://schemas.openxmlformats.org/drawingml/2006/main">
             <a:pPr algn="l">
+              <a:buNone/>
               <a:defRPr sz="1425" b="1">
                 <a:solidFill>
                   <a:srgbClr val="FFFFFF"/>
@@ -9029,6 +9156,7 @@
           <a:lstStyle xmlns:a="http://schemas.openxmlformats.org/drawingml/2006/main"/>
           <a:p xmlns:a="http://schemas.openxmlformats.org/drawingml/2006/main">
             <a:pPr algn="l">
+              <a:buNone/>
               <a:defRPr sz="900" b="1">
                 <a:solidFill>
                   <a:srgbClr val="C0562B"/>
@@ -9079,6 +9207,7 @@
           <a:lstStyle xmlns:a="http://schemas.openxmlformats.org/drawingml/2006/main"/>
           <a:p xmlns:a="http://schemas.openxmlformats.org/drawingml/2006/main">
             <a:pPr algn="l">
+              <a:buNone/>
               <a:defRPr sz="1425" b="1">
                 <a:solidFill>
                   <a:srgbClr val="FFFFFF"/>
@@ -9129,6 +9258,7 @@
           <a:lstStyle xmlns:a="http://schemas.openxmlformats.org/drawingml/2006/main"/>
           <a:p xmlns:a="http://schemas.openxmlformats.org/drawingml/2006/main">
             <a:pPr algn="l">
+              <a:buNone/>
               <a:defRPr sz="900" b="1">
                 <a:solidFill>
                   <a:srgbClr val="C0562B"/>
@@ -9179,6 +9309,7 @@
           <a:lstStyle xmlns:a="http://schemas.openxmlformats.org/drawingml/2006/main"/>
           <a:p xmlns:a="http://schemas.openxmlformats.org/drawingml/2006/main">
             <a:pPr algn="l">
+              <a:buNone/>
               <a:defRPr sz="1425" b="1">
                 <a:solidFill>
                   <a:srgbClr val="FFFFFF"/>
@@ -9229,6 +9360,7 @@
           <a:lstStyle xmlns:a="http://schemas.openxmlformats.org/drawingml/2006/main"/>
           <a:p xmlns:a="http://schemas.openxmlformats.org/drawingml/2006/main">
             <a:pPr algn="l">
+              <a:buNone/>
               <a:defRPr sz="1500" b="1">
                 <a:solidFill>
                   <a:srgbClr val="18A999"/>
@@ -9279,6 +9411,7 @@
           <a:lstStyle xmlns:a="http://schemas.openxmlformats.org/drawingml/2006/main"/>
           <a:p xmlns:a="http://schemas.openxmlformats.org/drawingml/2006/main">
             <a:pPr algn="r">
+              <a:buNone/>
               <a:defRPr sz="1050" b="0">
                 <a:solidFill>
                   <a:srgbClr val="AEB8C8"/>
@@ -9358,6 +9491,7 @@
           <a:lstStyle xmlns:a="http://schemas.openxmlformats.org/drawingml/2006/main"/>
           <a:p xmlns:a="http://schemas.openxmlformats.org/drawingml/2006/main">
             <a:pPr algn="r">
+              <a:buNone/>
               <a:defRPr sz="825" b="1">
                 <a:solidFill>
                   <a:srgbClr val="687386"/>
@@ -9408,6 +9542,7 @@
           <a:lstStyle xmlns:a="http://schemas.openxmlformats.org/drawingml/2006/main"/>
           <a:p xmlns:a="http://schemas.openxmlformats.org/drawingml/2006/main">
             <a:pPr algn="l">
+              <a:buNone/>
               <a:defRPr sz="900" b="1">
                 <a:solidFill>
                   <a:srgbClr val="C0562B"/>
@@ -9458,6 +9593,7 @@
           <a:lstStyle xmlns:a="http://schemas.openxmlformats.org/drawingml/2006/main"/>
           <a:p xmlns:a="http://schemas.openxmlformats.org/drawingml/2006/main">
             <a:pPr algn="l">
+              <a:buNone/>
               <a:defRPr sz="3750" b="1">
                 <a:solidFill>
                   <a:srgbClr val="1B2A4A"/>
@@ -9475,6 +9611,7 @@
           </a:p>
           <a:p xmlns:a="http://schemas.openxmlformats.org/drawingml/2006/main">
             <a:pPr algn="l">
+              <a:buNone/>
               <a:defRPr sz="3750" b="1">
                 <a:solidFill>
                   <a:srgbClr val="1B2A4A"/>
@@ -9525,6 +9662,7 @@
           <a:lstStyle xmlns:a="http://schemas.openxmlformats.org/drawingml/2006/main"/>
           <a:p xmlns:a="http://schemas.openxmlformats.org/drawingml/2006/main">
             <a:pPr algn="l">
+              <a:buNone/>
               <a:defRPr sz="1800" b="0">
                 <a:solidFill>
                   <a:srgbClr val="3F4A59"/>
@@ -9606,6 +9744,7 @@
           <a:lstStyle xmlns:a="http://schemas.openxmlformats.org/drawingml/2006/main"/>
           <a:p xmlns:a="http://schemas.openxmlformats.org/drawingml/2006/main">
             <a:pPr algn="l">
+              <a:buNone/>
               <a:defRPr sz="1500" b="1">
                 <a:solidFill>
                   <a:srgbClr val="C0562B"/>
@@ -9656,6 +9795,7 @@
           <a:lstStyle xmlns:a="http://schemas.openxmlformats.org/drawingml/2006/main"/>
           <a:p xmlns:a="http://schemas.openxmlformats.org/drawingml/2006/main">
             <a:pPr algn="l">
+              <a:buNone/>
               <a:defRPr sz="1500" b="1">
                 <a:solidFill>
                   <a:srgbClr val="D98C1F"/>
@@ -9706,6 +9846,7 @@
           <a:lstStyle xmlns:a="http://schemas.openxmlformats.org/drawingml/2006/main"/>
           <a:p xmlns:a="http://schemas.openxmlformats.org/drawingml/2006/main">
             <a:pPr algn="l">
+              <a:buNone/>
               <a:defRPr sz="1500" b="1">
                 <a:solidFill>
                   <a:srgbClr val="18A999"/>
@@ -9785,6 +9926,7 @@
           <a:lstStyle xmlns:a="http://schemas.openxmlformats.org/drawingml/2006/main"/>
           <a:p xmlns:a="http://schemas.openxmlformats.org/drawingml/2006/main">
             <a:pPr algn="r">
+              <a:buNone/>
               <a:defRPr sz="825" b="1">
                 <a:solidFill>
                   <a:srgbClr val="687386"/>
@@ -9835,6 +9977,7 @@
           <a:lstStyle xmlns:a="http://schemas.openxmlformats.org/drawingml/2006/main"/>
           <a:p xmlns:a="http://schemas.openxmlformats.org/drawingml/2006/main">
             <a:pPr algn="l">
+              <a:buNone/>
               <a:defRPr sz="900" b="1">
                 <a:solidFill>
                   <a:srgbClr val="18A999"/>
@@ -9885,6 +10028,7 @@
           <a:lstStyle xmlns:a="http://schemas.openxmlformats.org/drawingml/2006/main"/>
           <a:p xmlns:a="http://schemas.openxmlformats.org/drawingml/2006/main">
             <a:pPr algn="l">
+              <a:buNone/>
               <a:defRPr sz="2850" b="1">
                 <a:solidFill>
                   <a:srgbClr val="1B2A4A"/>
@@ -9935,6 +10079,7 @@
           <a:lstStyle xmlns:a="http://schemas.openxmlformats.org/drawingml/2006/main"/>
           <a:p xmlns:a="http://schemas.openxmlformats.org/drawingml/2006/main">
             <a:pPr algn="l">
+              <a:buNone/>
               <a:defRPr sz="1425" b="0">
                 <a:solidFill>
                   <a:srgbClr val="687386"/>
@@ -9985,6 +10130,7 @@
           <a:lstStyle xmlns:a="http://schemas.openxmlformats.org/drawingml/2006/main"/>
           <a:p xmlns:a="http://schemas.openxmlformats.org/drawingml/2006/main">
             <a:pPr algn="ctr">
+              <a:buNone/>
               <a:defRPr sz="2400" b="0">
                 <a:solidFill>
                   <a:srgbClr val="9AA3B0"/>
@@ -10035,6 +10181,7 @@
           <a:lstStyle xmlns:a="http://schemas.openxmlformats.org/drawingml/2006/main"/>
           <a:p xmlns:a="http://schemas.openxmlformats.org/drawingml/2006/main">
             <a:pPr algn="ctr">
+              <a:buNone/>
               <a:defRPr sz="2400" b="0">
                 <a:solidFill>
                   <a:srgbClr val="9AA3B0"/>
@@ -10190,6 +10337,7 @@
           <a:lstStyle xmlns:a="http://schemas.openxmlformats.org/drawingml/2006/main"/>
           <a:p xmlns:a="http://schemas.openxmlformats.org/drawingml/2006/main">
             <a:pPr algn="l">
+              <a:buNone/>
               <a:defRPr sz="1125" b="1">
                 <a:solidFill>
                   <a:srgbClr val="1B2A4A"/>
@@ -10240,6 +10388,7 @@
           <a:lstStyle xmlns:a="http://schemas.openxmlformats.org/drawingml/2006/main"/>
           <a:p xmlns:a="http://schemas.openxmlformats.org/drawingml/2006/main">
             <a:pPr algn="l">
+              <a:buNone/>
               <a:defRPr sz="1500" b="0">
                 <a:solidFill>
                   <a:srgbClr val="3F4A59"/>
@@ -10257,6 +10406,7 @@
           </a:p>
           <a:p xmlns:a="http://schemas.openxmlformats.org/drawingml/2006/main">
             <a:pPr algn="l">
+              <a:buNone/>
               <a:defRPr sz="1500" b="0">
                 <a:solidFill>
                   <a:srgbClr val="3F4A59"/>
@@ -10307,6 +10457,7 @@
           <a:lstStyle xmlns:a="http://schemas.openxmlformats.org/drawingml/2006/main"/>
           <a:p xmlns:a="http://schemas.openxmlformats.org/drawingml/2006/main">
             <a:pPr algn="ctr">
+              <a:buNone/>
               <a:defRPr sz="2100" b="1">
                 <a:solidFill>
                   <a:srgbClr val="FFFFFF"/>
@@ -10324,6 +10475,7 @@
           </a:p>
           <a:p xmlns:a="http://schemas.openxmlformats.org/drawingml/2006/main">
             <a:pPr algn="ctr">
+              <a:buNone/>
               <a:defRPr sz="2100" b="1">
                 <a:solidFill>
                   <a:srgbClr val="FFFFFF"/>
@@ -10374,6 +10526,7 @@
           <a:lstStyle xmlns:a="http://schemas.openxmlformats.org/drawingml/2006/main"/>
           <a:p xmlns:a="http://schemas.openxmlformats.org/drawingml/2006/main">
             <a:pPr algn="ctr">
+              <a:buNone/>
               <a:defRPr sz="1350" b="0">
                 <a:solidFill>
                   <a:srgbClr val="DCE3EE"/>
@@ -10391,6 +10544,7 @@
           </a:p>
           <a:p xmlns:a="http://schemas.openxmlformats.org/drawingml/2006/main">
             <a:pPr algn="ctr">
+              <a:buNone/>
               <a:defRPr sz="1350" b="0">
                 <a:solidFill>
                   <a:srgbClr val="DCE3EE"/>
@@ -10408,6 +10562,7 @@
           </a:p>
           <a:p xmlns:a="http://schemas.openxmlformats.org/drawingml/2006/main">
             <a:pPr algn="ctr">
+              <a:buNone/>
               <a:defRPr sz="1350" b="0">
                 <a:solidFill>
                   <a:srgbClr val="DCE3EE"/>
@@ -10458,6 +10613,7 @@
           <a:lstStyle xmlns:a="http://schemas.openxmlformats.org/drawingml/2006/main"/>
           <a:p xmlns:a="http://schemas.openxmlformats.org/drawingml/2006/main">
             <a:pPr algn="l">
+              <a:buNone/>
               <a:defRPr sz="1125" b="1">
                 <a:solidFill>
                   <a:srgbClr val="18A999"/>
@@ -10508,6 +10664,7 @@
           <a:lstStyle xmlns:a="http://schemas.openxmlformats.org/drawingml/2006/main"/>
           <a:p xmlns:a="http://schemas.openxmlformats.org/drawingml/2006/main">
             <a:pPr algn="l">
+              <a:buNone/>
               <a:defRPr sz="1500" b="0">
                 <a:solidFill>
                   <a:srgbClr val="3F4A59"/>
@@ -10525,6 +10682,7 @@
           </a:p>
           <a:p xmlns:a="http://schemas.openxmlformats.org/drawingml/2006/main">
             <a:pPr algn="l">
+              <a:buNone/>
               <a:defRPr sz="1500" b="0">
                 <a:solidFill>
                   <a:srgbClr val="3F4A59"/>
@@ -10604,6 +10762,7 @@
           <a:lstStyle xmlns:a="http://schemas.openxmlformats.org/drawingml/2006/main"/>
           <a:p xmlns:a="http://schemas.openxmlformats.org/drawingml/2006/main">
             <a:pPr algn="r">
+              <a:buNone/>
               <a:defRPr sz="825" b="1">
                 <a:solidFill>
                   <a:srgbClr val="B8C0CE"/>
@@ -10654,6 +10813,7 @@
           <a:lstStyle xmlns:a="http://schemas.openxmlformats.org/drawingml/2006/main"/>
           <a:p xmlns:a="http://schemas.openxmlformats.org/drawingml/2006/main">
             <a:pPr algn="l">
+              <a:buNone/>
               <a:defRPr sz="900" b="1">
                 <a:solidFill>
                   <a:srgbClr val="18A999"/>
@@ -10704,6 +10864,7 @@
           <a:lstStyle xmlns:a="http://schemas.openxmlformats.org/drawingml/2006/main"/>
           <a:p xmlns:a="http://schemas.openxmlformats.org/drawingml/2006/main">
             <a:pPr algn="l">
+              <a:buNone/>
               <a:defRPr sz="3150" b="1">
                 <a:solidFill>
                   <a:srgbClr val="FFFFFF"/>
@@ -10785,6 +10946,7 @@
           <a:lstStyle xmlns:a="http://schemas.openxmlformats.org/drawingml/2006/main"/>
           <a:p xmlns:a="http://schemas.openxmlformats.org/drawingml/2006/main">
             <a:pPr algn="l">
+              <a:buNone/>
               <a:defRPr sz="1500" b="1">
                 <a:solidFill>
                   <a:srgbClr val="8FE2D8"/>
@@ -10835,6 +10997,7 @@
           <a:lstStyle xmlns:a="http://schemas.openxmlformats.org/drawingml/2006/main"/>
           <a:p xmlns:a="http://schemas.openxmlformats.org/drawingml/2006/main">
             <a:pPr algn="l">
+              <a:buNone/>
               <a:defRPr sz="2175" b="1">
                 <a:solidFill>
                   <a:srgbClr val="FFFFFF"/>
@@ -10852,6 +11015,7 @@
           </a:p>
           <a:p xmlns:a="http://schemas.openxmlformats.org/drawingml/2006/main">
             <a:pPr algn="l">
+              <a:buNone/>
               <a:defRPr sz="2175" b="1">
                 <a:solidFill>
                   <a:srgbClr val="FFFFFF"/>
@@ -10902,6 +11066,7 @@
           <a:lstStyle xmlns:a="http://schemas.openxmlformats.org/drawingml/2006/main"/>
           <a:p xmlns:a="http://schemas.openxmlformats.org/drawingml/2006/main">
             <a:pPr algn="l">
+              <a:buNone/>
               <a:defRPr sz="1500" b="0">
                 <a:solidFill>
                   <a:srgbClr val="C5CDDA"/>
@@ -10919,6 +11084,7 @@
           </a:p>
           <a:p xmlns:a="http://schemas.openxmlformats.org/drawingml/2006/main">
             <a:pPr algn="l">
+              <a:buNone/>
               <a:defRPr sz="1500" b="0">
                 <a:solidFill>
                   <a:srgbClr val="C5CDDA"/>
@@ -10969,6 +11135,7 @@
           <a:lstStyle xmlns:a="http://schemas.openxmlformats.org/drawingml/2006/main"/>
           <a:p xmlns:a="http://schemas.openxmlformats.org/drawingml/2006/main">
             <a:pPr algn="l">
+              <a:buNone/>
               <a:defRPr sz="1500" b="1">
                 <a:solidFill>
                   <a:srgbClr val="F4C08B"/>
@@ -11019,6 +11186,7 @@
           <a:lstStyle xmlns:a="http://schemas.openxmlformats.org/drawingml/2006/main"/>
           <a:p xmlns:a="http://schemas.openxmlformats.org/drawingml/2006/main">
             <a:pPr algn="l">
+              <a:buNone/>
               <a:defRPr sz="2175" b="1">
                 <a:solidFill>
                   <a:srgbClr val="FFFFFF"/>
@@ -11036,6 +11204,7 @@
           </a:p>
           <a:p xmlns:a="http://schemas.openxmlformats.org/drawingml/2006/main">
             <a:pPr algn="l">
+              <a:buNone/>
               <a:defRPr sz="2175" b="1">
                 <a:solidFill>
                   <a:srgbClr val="FFFFFF"/>
@@ -11086,6 +11255,7 @@
           <a:lstStyle xmlns:a="http://schemas.openxmlformats.org/drawingml/2006/main"/>
           <a:p xmlns:a="http://schemas.openxmlformats.org/drawingml/2006/main">
             <a:pPr algn="l">
+              <a:buNone/>
               <a:defRPr sz="1500" b="0">
                 <a:solidFill>
                   <a:srgbClr val="C5CDDA"/>
@@ -11103,6 +11273,7 @@
           </a:p>
           <a:p xmlns:a="http://schemas.openxmlformats.org/drawingml/2006/main">
             <a:pPr algn="l">
+              <a:buNone/>
               <a:defRPr sz="1500" b="0">
                 <a:solidFill>
                   <a:srgbClr val="C5CDDA"/>
@@ -11153,6 +11324,7 @@
           <a:lstStyle xmlns:a="http://schemas.openxmlformats.org/drawingml/2006/main"/>
           <a:p xmlns:a="http://schemas.openxmlformats.org/drawingml/2006/main">
             <a:pPr algn="l">
+              <a:buNone/>
               <a:defRPr sz="1500" b="1">
                 <a:solidFill>
                   <a:srgbClr val="FFFFFF"/>
@@ -11232,6 +11404,7 @@
           <a:lstStyle xmlns:a="http://schemas.openxmlformats.org/drawingml/2006/main"/>
           <a:p xmlns:a="http://schemas.openxmlformats.org/drawingml/2006/main">
             <a:pPr algn="r">
+              <a:buNone/>
               <a:defRPr sz="825" b="1">
                 <a:solidFill>
                   <a:srgbClr val="687386"/>
@@ -11282,6 +11455,7 @@
           <a:lstStyle xmlns:a="http://schemas.openxmlformats.org/drawingml/2006/main"/>
           <a:p xmlns:a="http://schemas.openxmlformats.org/drawingml/2006/main">
             <a:pPr algn="l">
+              <a:buNone/>
               <a:defRPr sz="900" b="1">
                 <a:solidFill>
                   <a:srgbClr val="18A999"/>
@@ -11332,6 +11506,7 @@
           <a:lstStyle xmlns:a="http://schemas.openxmlformats.org/drawingml/2006/main"/>
           <a:p xmlns:a="http://schemas.openxmlformats.org/drawingml/2006/main">
             <a:pPr algn="l">
+              <a:buNone/>
               <a:defRPr sz="2850" b="1">
                 <a:solidFill>
                   <a:srgbClr val="1B2A4A"/>
@@ -11382,6 +11557,7 @@
           <a:lstStyle xmlns:a="http://schemas.openxmlformats.org/drawingml/2006/main"/>
           <a:p xmlns:a="http://schemas.openxmlformats.org/drawingml/2006/main">
             <a:pPr algn="l">
+              <a:buNone/>
               <a:defRPr sz="1425" b="0">
                 <a:solidFill>
                   <a:srgbClr val="687386"/>
@@ -11432,6 +11608,7 @@
           <a:lstStyle xmlns:a="http://schemas.openxmlformats.org/drawingml/2006/main"/>
           <a:p xmlns:a="http://schemas.openxmlformats.org/drawingml/2006/main">
             <a:pPr algn="ctr">
+              <a:buNone/>
               <a:defRPr sz="2025" b="1">
                 <a:solidFill>
                   <a:srgbClr val="1B2A4A"/>
@@ -11513,6 +11690,7 @@
           <a:lstStyle xmlns:a="http://schemas.openxmlformats.org/drawingml/2006/main"/>
           <a:p xmlns:a="http://schemas.openxmlformats.org/drawingml/2006/main">
             <a:pPr algn="ctr">
+              <a:buNone/>
               <a:defRPr sz="2025" b="1">
                 <a:solidFill>
                   <a:srgbClr val="1B2A4A"/>
@@ -11594,6 +11772,7 @@
           <a:lstStyle xmlns:a="http://schemas.openxmlformats.org/drawingml/2006/main"/>
           <a:p xmlns:a="http://schemas.openxmlformats.org/drawingml/2006/main">
             <a:pPr algn="ctr">
+              <a:buNone/>
               <a:defRPr sz="2025" b="1">
                 <a:solidFill>
                   <a:srgbClr val="1B2A4A"/>
@@ -11675,6 +11854,7 @@
           <a:lstStyle xmlns:a="http://schemas.openxmlformats.org/drawingml/2006/main"/>
           <a:p xmlns:a="http://schemas.openxmlformats.org/drawingml/2006/main">
             <a:pPr algn="ctr">
+              <a:buNone/>
               <a:defRPr sz="2100" b="1">
                 <a:solidFill>
                   <a:srgbClr val="18A999"/>
@@ -11756,6 +11936,7 @@
           <a:lstStyle xmlns:a="http://schemas.openxmlformats.org/drawingml/2006/main"/>
           <a:p xmlns:a="http://schemas.openxmlformats.org/drawingml/2006/main">
             <a:pPr algn="ctr">
+              <a:buNone/>
               <a:defRPr sz="2025" b="1">
                 <a:solidFill>
                   <a:srgbClr val="1B2A4A"/>
@@ -11837,6 +12018,7 @@
           <a:lstStyle xmlns:a="http://schemas.openxmlformats.org/drawingml/2006/main"/>
           <a:p xmlns:a="http://schemas.openxmlformats.org/drawingml/2006/main">
             <a:pPr algn="ctr">
+              <a:buNone/>
               <a:defRPr sz="2025" b="1">
                 <a:solidFill>
                   <a:srgbClr val="1B2A4A"/>
@@ -11918,6 +12100,7 @@
           <a:lstStyle xmlns:a="http://schemas.openxmlformats.org/drawingml/2006/main"/>
           <a:p xmlns:a="http://schemas.openxmlformats.org/drawingml/2006/main">
             <a:pPr algn="ctr">
+              <a:buNone/>
               <a:defRPr sz="2025" b="1">
                 <a:solidFill>
                   <a:srgbClr val="C0562B"/>
@@ -11999,6 +12182,7 @@
           <a:lstStyle xmlns:a="http://schemas.openxmlformats.org/drawingml/2006/main"/>
           <a:p xmlns:a="http://schemas.openxmlformats.org/drawingml/2006/main">
             <a:pPr algn="ctr">
+              <a:buNone/>
               <a:defRPr sz="1575" b="1">
                 <a:solidFill>
                   <a:srgbClr val="3F4A59"/>
@@ -12078,6 +12262,7 @@
           <a:lstStyle xmlns:a="http://schemas.openxmlformats.org/drawingml/2006/main"/>
           <a:p xmlns:a="http://schemas.openxmlformats.org/drawingml/2006/main">
             <a:pPr algn="r">
+              <a:buNone/>
               <a:defRPr sz="825" b="1">
                 <a:solidFill>
                   <a:srgbClr val="687386"/>
@@ -12128,6 +12313,7 @@
           <a:lstStyle xmlns:a="http://schemas.openxmlformats.org/drawingml/2006/main"/>
           <a:p xmlns:a="http://schemas.openxmlformats.org/drawingml/2006/main">
             <a:pPr algn="l">
+              <a:buNone/>
               <a:defRPr sz="900" b="1">
                 <a:solidFill>
                   <a:srgbClr val="18A999"/>
@@ -12178,6 +12364,7 @@
           <a:lstStyle xmlns:a="http://schemas.openxmlformats.org/drawingml/2006/main"/>
           <a:p xmlns:a="http://schemas.openxmlformats.org/drawingml/2006/main">
             <a:pPr algn="l">
+              <a:buNone/>
               <a:defRPr sz="3150" b="1">
                 <a:solidFill>
                   <a:srgbClr val="1B2A4A"/>
@@ -12228,6 +12415,7 @@
           <a:lstStyle xmlns:a="http://schemas.openxmlformats.org/drawingml/2006/main"/>
           <a:p xmlns:a="http://schemas.openxmlformats.org/drawingml/2006/main">
             <a:pPr algn="l">
+              <a:buNone/>
               <a:defRPr sz="975" b="1">
                 <a:solidFill>
                   <a:srgbClr val="C0562B"/>
@@ -12278,6 +12466,7 @@
           <a:lstStyle xmlns:a="http://schemas.openxmlformats.org/drawingml/2006/main"/>
           <a:p xmlns:a="http://schemas.openxmlformats.org/drawingml/2006/main">
             <a:pPr algn="l">
+              <a:buNone/>
               <a:defRPr sz="1500" b="1">
                 <a:solidFill>
                   <a:srgbClr val="1B2A4A"/>
@@ -12328,6 +12517,7 @@
           <a:lstStyle xmlns:a="http://schemas.openxmlformats.org/drawingml/2006/main"/>
           <a:p xmlns:a="http://schemas.openxmlformats.org/drawingml/2006/main">
             <a:pPr algn="l">
+              <a:buNone/>
               <a:defRPr sz="1350" b="0">
                 <a:solidFill>
                   <a:srgbClr val="3F4A59"/>
@@ -12378,6 +12568,7 @@
           <a:lstStyle xmlns:a="http://schemas.openxmlformats.org/drawingml/2006/main"/>
           <a:p xmlns:a="http://schemas.openxmlformats.org/drawingml/2006/main">
             <a:pPr algn="l">
+              <a:buNone/>
               <a:defRPr sz="975" b="1">
                 <a:solidFill>
                   <a:srgbClr val="C0562B"/>
@@ -12428,6 +12619,7 @@
           <a:lstStyle xmlns:a="http://schemas.openxmlformats.org/drawingml/2006/main"/>
           <a:p xmlns:a="http://schemas.openxmlformats.org/drawingml/2006/main">
             <a:pPr algn="l">
+              <a:buNone/>
               <a:defRPr sz="1500" b="1">
                 <a:solidFill>
                   <a:srgbClr val="1B2A4A"/>
@@ -12478,6 +12670,7 @@
           <a:lstStyle xmlns:a="http://schemas.openxmlformats.org/drawingml/2006/main"/>
           <a:p xmlns:a="http://schemas.openxmlformats.org/drawingml/2006/main">
             <a:pPr algn="l">
+              <a:buNone/>
               <a:defRPr sz="1350" b="0">
                 <a:solidFill>
                   <a:srgbClr val="3F4A59"/>
@@ -12528,6 +12721,7 @@
           <a:lstStyle xmlns:a="http://schemas.openxmlformats.org/drawingml/2006/main"/>
           <a:p xmlns:a="http://schemas.openxmlformats.org/drawingml/2006/main">
             <a:pPr algn="l">
+              <a:buNone/>
               <a:defRPr sz="975" b="1">
                 <a:solidFill>
                   <a:srgbClr val="C0562B"/>
@@ -12578,6 +12772,7 @@
           <a:lstStyle xmlns:a="http://schemas.openxmlformats.org/drawingml/2006/main"/>
           <a:p xmlns:a="http://schemas.openxmlformats.org/drawingml/2006/main">
             <a:pPr algn="l">
+              <a:buNone/>
               <a:defRPr sz="1500" b="1">
                 <a:solidFill>
                   <a:srgbClr val="1B2A4A"/>
@@ -12628,6 +12823,7 @@
           <a:lstStyle xmlns:a="http://schemas.openxmlformats.org/drawingml/2006/main"/>
           <a:p xmlns:a="http://schemas.openxmlformats.org/drawingml/2006/main">
             <a:pPr algn="l">
+              <a:buNone/>
               <a:defRPr sz="1350" b="0">
                 <a:solidFill>
                   <a:srgbClr val="3F4A59"/>
@@ -12678,6 +12874,7 @@
           <a:lstStyle xmlns:a="http://schemas.openxmlformats.org/drawingml/2006/main"/>
           <a:p xmlns:a="http://schemas.openxmlformats.org/drawingml/2006/main">
             <a:pPr algn="l">
+              <a:buNone/>
               <a:defRPr sz="975" b="1">
                 <a:solidFill>
                   <a:srgbClr val="C0562B"/>
@@ -12728,6 +12925,7 @@
           <a:lstStyle xmlns:a="http://schemas.openxmlformats.org/drawingml/2006/main"/>
           <a:p xmlns:a="http://schemas.openxmlformats.org/drawingml/2006/main">
             <a:pPr algn="l">
+              <a:buNone/>
               <a:defRPr sz="1500" b="1">
                 <a:solidFill>
                   <a:srgbClr val="1B2A4A"/>
@@ -12778,6 +12976,7 @@
           <a:lstStyle xmlns:a="http://schemas.openxmlformats.org/drawingml/2006/main"/>
           <a:p xmlns:a="http://schemas.openxmlformats.org/drawingml/2006/main">
             <a:pPr algn="l">
+              <a:buNone/>
               <a:defRPr sz="1350" b="0">
                 <a:solidFill>
                   <a:srgbClr val="3F4A59"/>
@@ -12828,6 +13027,7 @@
           <a:lstStyle xmlns:a="http://schemas.openxmlformats.org/drawingml/2006/main"/>
           <a:p xmlns:a="http://schemas.openxmlformats.org/drawingml/2006/main">
             <a:pPr algn="l">
+              <a:buNone/>
               <a:defRPr sz="975" b="1">
                 <a:solidFill>
                   <a:srgbClr val="C0562B"/>
@@ -12878,6 +13078,7 @@
           <a:lstStyle xmlns:a="http://schemas.openxmlformats.org/drawingml/2006/main"/>
           <a:p xmlns:a="http://schemas.openxmlformats.org/drawingml/2006/main">
             <a:pPr algn="l">
+              <a:buNone/>
               <a:defRPr sz="1500" b="1">
                 <a:solidFill>
                   <a:srgbClr val="1B2A4A"/>
@@ -12928,6 +13129,7 @@
           <a:lstStyle xmlns:a="http://schemas.openxmlformats.org/drawingml/2006/main"/>
           <a:p xmlns:a="http://schemas.openxmlformats.org/drawingml/2006/main">
             <a:pPr algn="l">
+              <a:buNone/>
               <a:defRPr sz="1350" b="0">
                 <a:solidFill>
                   <a:srgbClr val="3F4A59"/>
@@ -12978,6 +13180,7 @@
           <a:lstStyle xmlns:a="http://schemas.openxmlformats.org/drawingml/2006/main"/>
           <a:p xmlns:a="http://schemas.openxmlformats.org/drawingml/2006/main">
             <a:pPr algn="l">
+              <a:buNone/>
               <a:defRPr sz="975" b="1">
                 <a:solidFill>
                   <a:srgbClr val="C0562B"/>
@@ -13028,6 +13231,7 @@
           <a:lstStyle xmlns:a="http://schemas.openxmlformats.org/drawingml/2006/main"/>
           <a:p xmlns:a="http://schemas.openxmlformats.org/drawingml/2006/main">
             <a:pPr algn="l">
+              <a:buNone/>
               <a:defRPr sz="1500" b="1">
                 <a:solidFill>
                   <a:srgbClr val="1B2A4A"/>
@@ -13078,6 +13282,7 @@
           <a:lstStyle xmlns:a="http://schemas.openxmlformats.org/drawingml/2006/main"/>
           <a:p xmlns:a="http://schemas.openxmlformats.org/drawingml/2006/main">
             <a:pPr algn="l">
+              <a:buNone/>
               <a:defRPr sz="1350" b="0">
                 <a:solidFill>
                   <a:srgbClr val="3F4A59"/>
@@ -13157,6 +13362,7 @@
           <a:lstStyle xmlns:a="http://schemas.openxmlformats.org/drawingml/2006/main"/>
           <a:p xmlns:a="http://schemas.openxmlformats.org/drawingml/2006/main">
             <a:pPr algn="r">
+              <a:buNone/>
               <a:defRPr sz="825" b="1">
                 <a:solidFill>
                   <a:srgbClr val="687386"/>
@@ -13207,6 +13413,7 @@
           <a:lstStyle xmlns:a="http://schemas.openxmlformats.org/drawingml/2006/main"/>
           <a:p xmlns:a="http://schemas.openxmlformats.org/drawingml/2006/main">
             <a:pPr algn="l">
+              <a:buNone/>
               <a:defRPr sz="900" b="1">
                 <a:solidFill>
                   <a:srgbClr val="18A999"/>
@@ -13257,6 +13464,7 @@
           <a:lstStyle xmlns:a="http://schemas.openxmlformats.org/drawingml/2006/main"/>
           <a:p xmlns:a="http://schemas.openxmlformats.org/drawingml/2006/main">
             <a:pPr algn="l">
+              <a:buNone/>
               <a:defRPr sz="2850" b="1">
                 <a:solidFill>
                   <a:srgbClr val="1B2A4A"/>
@@ -13307,6 +13515,7 @@
           <a:lstStyle xmlns:a="http://schemas.openxmlformats.org/drawingml/2006/main"/>
           <a:p xmlns:a="http://schemas.openxmlformats.org/drawingml/2006/main">
             <a:pPr algn="l">
+              <a:buNone/>
               <a:defRPr sz="1425" b="0">
                 <a:solidFill>
                   <a:srgbClr val="687386"/>
@@ -13390,6 +13599,7 @@
           <a:lstStyle xmlns:a="http://schemas.openxmlformats.org/drawingml/2006/main"/>
           <a:p xmlns:a="http://schemas.openxmlformats.org/drawingml/2006/main">
             <a:pPr algn="l">
+              <a:buNone/>
               <a:defRPr sz="1050" b="1">
                 <a:solidFill>
                   <a:srgbClr val="1B2A4A"/>
@@ -13440,6 +13650,7 @@
           <a:lstStyle xmlns:a="http://schemas.openxmlformats.org/drawingml/2006/main"/>
           <a:p xmlns:a="http://schemas.openxmlformats.org/drawingml/2006/main">
             <a:pPr algn="l">
+              <a:buNone/>
               <a:defRPr sz="1350" b="1">
                 <a:solidFill>
                   <a:srgbClr val="1B2A4A"/>
@@ -13490,6 +13701,7 @@
           <a:lstStyle xmlns:a="http://schemas.openxmlformats.org/drawingml/2006/main"/>
           <a:p xmlns:a="http://schemas.openxmlformats.org/drawingml/2006/main">
             <a:pPr algn="r">
+              <a:buNone/>
               <a:defRPr sz="1200" b="0">
                 <a:solidFill>
                   <a:srgbClr val="3F4A59"/>
@@ -13573,6 +13785,7 @@
           <a:lstStyle xmlns:a="http://schemas.openxmlformats.org/drawingml/2006/main"/>
           <a:p xmlns:a="http://schemas.openxmlformats.org/drawingml/2006/main">
             <a:pPr algn="l">
+              <a:buNone/>
               <a:defRPr sz="1050" b="1">
                 <a:solidFill>
                   <a:srgbClr val="1B2A4A"/>
@@ -13623,6 +13836,7 @@
           <a:lstStyle xmlns:a="http://schemas.openxmlformats.org/drawingml/2006/main"/>
           <a:p xmlns:a="http://schemas.openxmlformats.org/drawingml/2006/main">
             <a:pPr algn="l">
+              <a:buNone/>
               <a:defRPr sz="1350" b="1">
                 <a:solidFill>
                   <a:srgbClr val="1B2A4A"/>
@@ -13673,6 +13887,7 @@
           <a:lstStyle xmlns:a="http://schemas.openxmlformats.org/drawingml/2006/main"/>
           <a:p xmlns:a="http://schemas.openxmlformats.org/drawingml/2006/main">
             <a:pPr algn="r">
+              <a:buNone/>
               <a:defRPr sz="1200" b="0">
                 <a:solidFill>
                   <a:srgbClr val="3F4A59"/>
@@ -13756,6 +13971,7 @@
           <a:lstStyle xmlns:a="http://schemas.openxmlformats.org/drawingml/2006/main"/>
           <a:p xmlns:a="http://schemas.openxmlformats.org/drawingml/2006/main">
             <a:pPr algn="l">
+              <a:buNone/>
               <a:defRPr sz="1050" b="1">
                 <a:solidFill>
                   <a:srgbClr val="18A999"/>
@@ -13806,6 +14022,7 @@
           <a:lstStyle xmlns:a="http://schemas.openxmlformats.org/drawingml/2006/main"/>
           <a:p xmlns:a="http://schemas.openxmlformats.org/drawingml/2006/main">
             <a:pPr algn="l">
+              <a:buNone/>
               <a:defRPr sz="1350" b="1">
                 <a:solidFill>
                   <a:srgbClr val="1B2A4A"/>
@@ -13856,6 +14073,7 @@
           <a:lstStyle xmlns:a="http://schemas.openxmlformats.org/drawingml/2006/main"/>
           <a:p xmlns:a="http://schemas.openxmlformats.org/drawingml/2006/main">
             <a:pPr algn="r">
+              <a:buNone/>
               <a:defRPr sz="1200" b="0">
                 <a:solidFill>
                   <a:srgbClr val="3F4A59"/>
@@ -13939,6 +14157,7 @@
           <a:lstStyle xmlns:a="http://schemas.openxmlformats.org/drawingml/2006/main"/>
           <a:p xmlns:a="http://schemas.openxmlformats.org/drawingml/2006/main">
             <a:pPr algn="l">
+              <a:buNone/>
               <a:defRPr sz="1050" b="1">
                 <a:solidFill>
                   <a:srgbClr val="18A999"/>
@@ -13989,6 +14208,7 @@
           <a:lstStyle xmlns:a="http://schemas.openxmlformats.org/drawingml/2006/main"/>
           <a:p xmlns:a="http://schemas.openxmlformats.org/drawingml/2006/main">
             <a:pPr algn="l">
+              <a:buNone/>
               <a:defRPr sz="1350" b="1">
                 <a:solidFill>
                   <a:srgbClr val="1B2A4A"/>
@@ -14039,6 +14259,7 @@
           <a:lstStyle xmlns:a="http://schemas.openxmlformats.org/drawingml/2006/main"/>
           <a:p xmlns:a="http://schemas.openxmlformats.org/drawingml/2006/main">
             <a:pPr algn="r">
+              <a:buNone/>
               <a:defRPr sz="1200" b="0">
                 <a:solidFill>
                   <a:srgbClr val="3F4A59"/>
@@ -14122,6 +14343,7 @@
           <a:lstStyle xmlns:a="http://schemas.openxmlformats.org/drawingml/2006/main"/>
           <a:p xmlns:a="http://schemas.openxmlformats.org/drawingml/2006/main">
             <a:pPr algn="l">
+              <a:buNone/>
               <a:defRPr sz="1050" b="1">
                 <a:solidFill>
                   <a:srgbClr val="C0562B"/>
@@ -14172,6 +14394,7 @@
           <a:lstStyle xmlns:a="http://schemas.openxmlformats.org/drawingml/2006/main"/>
           <a:p xmlns:a="http://schemas.openxmlformats.org/drawingml/2006/main">
             <a:pPr algn="l">
+              <a:buNone/>
               <a:defRPr sz="1350" b="1">
                 <a:solidFill>
                   <a:srgbClr val="1B2A4A"/>
@@ -14222,6 +14445,7 @@
           <a:lstStyle xmlns:a="http://schemas.openxmlformats.org/drawingml/2006/main"/>
           <a:p xmlns:a="http://schemas.openxmlformats.org/drawingml/2006/main">
             <a:pPr algn="r">
+              <a:buNone/>
               <a:defRPr sz="1200" b="0">
                 <a:solidFill>
                   <a:srgbClr val="3F4A59"/>
@@ -14305,6 +14529,7 @@
           <a:lstStyle xmlns:a="http://schemas.openxmlformats.org/drawingml/2006/main"/>
           <a:p xmlns:a="http://schemas.openxmlformats.org/drawingml/2006/main">
             <a:pPr algn="l">
+              <a:buNone/>
               <a:defRPr sz="1050" b="1">
                 <a:solidFill>
                   <a:srgbClr val="D98C1F"/>
@@ -14355,6 +14580,7 @@
           <a:lstStyle xmlns:a="http://schemas.openxmlformats.org/drawingml/2006/main"/>
           <a:p xmlns:a="http://schemas.openxmlformats.org/drawingml/2006/main">
             <a:pPr algn="l">
+              <a:buNone/>
               <a:defRPr sz="1350" b="1">
                 <a:solidFill>
                   <a:srgbClr val="1B2A4A"/>
@@ -14405,6 +14631,7 @@
           <a:lstStyle xmlns:a="http://schemas.openxmlformats.org/drawingml/2006/main"/>
           <a:p xmlns:a="http://schemas.openxmlformats.org/drawingml/2006/main">
             <a:pPr algn="r">
+              <a:buNone/>
               <a:defRPr sz="1200" b="0">
                 <a:solidFill>
                   <a:srgbClr val="3F4A59"/>
@@ -14484,6 +14711,7 @@
           <a:lstStyle xmlns:a="http://schemas.openxmlformats.org/drawingml/2006/main"/>
           <a:p xmlns:a="http://schemas.openxmlformats.org/drawingml/2006/main">
             <a:pPr algn="r">
+              <a:buNone/>
               <a:defRPr sz="825" b="1">
                 <a:solidFill>
                   <a:srgbClr val="B8C0CE"/>
@@ -14534,6 +14762,7 @@
           <a:lstStyle xmlns:a="http://schemas.openxmlformats.org/drawingml/2006/main"/>
           <a:p xmlns:a="http://schemas.openxmlformats.org/drawingml/2006/main">
             <a:pPr algn="l">
+              <a:buNone/>
               <a:defRPr sz="900" b="1">
                 <a:solidFill>
                   <a:srgbClr val="18A999"/>
@@ -14546,7 +14775,7 @@
                   <a:srgbClr val="18A999"/>
                 </a:solidFill>
               </a:rPr>
-              <a:t>THE ARTIFACT SYSTEM</a:t>
+              <a:t>THE DELIVERY SYSTEM</a:t>
             </a:r>
           </a:p>
         </p:txBody>
@@ -14584,6 +14813,7 @@
           <a:lstStyle xmlns:a="http://schemas.openxmlformats.org/drawingml/2006/main"/>
           <a:p xmlns:a="http://schemas.openxmlformats.org/drawingml/2006/main">
             <a:pPr algn="l">
+              <a:buNone/>
               <a:defRPr sz="3000" b="1">
                 <a:solidFill>
                   <a:srgbClr val="FFFFFF"/>
@@ -14596,7 +14826,7 @@
                   <a:srgbClr val="FFFFFF"/>
                 </a:solidFill>
               </a:rPr>
-              <a:t>One discipline. Three distinct proofs.</a:t>
+              <a:t>Two artifacts. Evidence in every lab.</a:t>
             </a:r>
           </a:p>
         </p:txBody>
@@ -14665,6 +14895,7 @@
           <a:lstStyle xmlns:a="http://schemas.openxmlformats.org/drawingml/2006/main"/>
           <a:p xmlns:a="http://schemas.openxmlformats.org/drawingml/2006/main">
             <a:pPr algn="ctr">
+              <a:buNone/>
               <a:defRPr sz="2100" b="1">
                 <a:solidFill>
                   <a:srgbClr val="FFFFFF"/>
@@ -14715,6 +14946,7 @@
           <a:lstStyle xmlns:a="http://schemas.openxmlformats.org/drawingml/2006/main"/>
           <a:p xmlns:a="http://schemas.openxmlformats.org/drawingml/2006/main">
             <a:pPr algn="ctr">
+              <a:buNone/>
               <a:defRPr sz="1500" b="1">
                 <a:solidFill>
                   <a:srgbClr val="C0562B"/>
@@ -14765,6 +14997,7 @@
           <a:lstStyle xmlns:a="http://schemas.openxmlformats.org/drawingml/2006/main"/>
           <a:p xmlns:a="http://schemas.openxmlformats.org/drawingml/2006/main">
             <a:pPr algn="ctr">
+              <a:buNone/>
               <a:defRPr sz="1350" b="0">
                 <a:solidFill>
                   <a:srgbClr val="C5CDDA"/>
@@ -14846,6 +15079,7 @@
           <a:lstStyle xmlns:a="http://schemas.openxmlformats.org/drawingml/2006/main"/>
           <a:p xmlns:a="http://schemas.openxmlformats.org/drawingml/2006/main">
             <a:pPr algn="ctr">
+              <a:buNone/>
               <a:defRPr sz="2100" b="1">
                 <a:solidFill>
                   <a:srgbClr val="FFFFFF"/>
@@ -14896,6 +15130,7 @@
           <a:lstStyle xmlns:a="http://schemas.openxmlformats.org/drawingml/2006/main"/>
           <a:p xmlns:a="http://schemas.openxmlformats.org/drawingml/2006/main">
             <a:pPr algn="ctr">
+              <a:buNone/>
               <a:defRPr sz="1500" b="1">
                 <a:solidFill>
                   <a:srgbClr val="18A999"/>
@@ -14946,6 +15181,7 @@
           <a:lstStyle xmlns:a="http://schemas.openxmlformats.org/drawingml/2006/main"/>
           <a:p xmlns:a="http://schemas.openxmlformats.org/drawingml/2006/main">
             <a:pPr algn="ctr">
+              <a:buNone/>
               <a:defRPr sz="1350" b="0">
                 <a:solidFill>
                   <a:srgbClr val="C5CDDA"/>
@@ -15027,6 +15263,7 @@
           <a:lstStyle xmlns:a="http://schemas.openxmlformats.org/drawingml/2006/main"/>
           <a:p xmlns:a="http://schemas.openxmlformats.org/drawingml/2006/main">
             <a:pPr algn="ctr">
+              <a:buNone/>
               <a:defRPr sz="2100" b="1">
                 <a:solidFill>
                   <a:srgbClr val="FFFFFF"/>
@@ -15039,7 +15276,7 @@
                   <a:srgbClr val="FFFFFF"/>
                 </a:solidFill>
               </a:rPr>
-              <a:t>loopbench</a:t>
+              <a:t>EVIDENCE</a:t>
             </a:r>
           </a:p>
         </p:txBody>
@@ -15077,6 +15314,7 @@
           <a:lstStyle xmlns:a="http://schemas.openxmlformats.org/drawingml/2006/main"/>
           <a:p xmlns:a="http://schemas.openxmlformats.org/drawingml/2006/main">
             <a:pPr algn="ctr">
+              <a:buNone/>
               <a:defRPr sz="1500" b="1">
                 <a:solidFill>
                   <a:srgbClr val="D98C1F"/>
@@ -15089,7 +15327,7 @@
                   <a:srgbClr val="D98C1F"/>
                 </a:solidFill>
               </a:rPr>
-              <a:t>makes measurement portable</a:t>
+              <a:t>makes decisions inspectable</a:t>
             </a:r>
           </a:p>
         </p:txBody>
@@ -15127,6 +15365,7 @@
           <a:lstStyle xmlns:a="http://schemas.openxmlformats.org/drawingml/2006/main"/>
           <a:p xmlns:a="http://schemas.openxmlformats.org/drawingml/2006/main">
             <a:pPr algn="ctr">
+              <a:buNone/>
               <a:defRPr sz="1350" b="0">
                 <a:solidFill>
                   <a:srgbClr val="C5CDDA"/>
@@ -15139,7 +15378,7 @@
                   <a:srgbClr val="C5CDDA"/>
                 </a:solidFill>
               </a:rPr>
-              <a:t>One protocol carries evidence across embodiments.</a:t>
+              <a:t>Every lab records its setup, uncertainty, result, and decision.</a:t>
             </a:r>
           </a:p>
         </p:txBody>
@@ -15177,6 +15416,7 @@
           <a:lstStyle xmlns:a="http://schemas.openxmlformats.org/drawingml/2006/main"/>
           <a:p xmlns:a="http://schemas.openxmlformats.org/drawingml/2006/main">
             <a:pPr algn="ctr">
+              <a:buNone/>
               <a:defRPr sz="1650" b="1">
                 <a:solidFill>
                   <a:srgbClr val="FFFFFF"/>
@@ -15189,7 +15429,7 @@
                   <a:srgbClr val="FFFFFF"/>
                 </a:solidFill>
               </a:rPr>
-              <a:t>None substitutes for the others.</a:t>
+              <a:t>Measurement stays inside the work.</a:t>
             </a:r>
           </a:p>
         </p:txBody>
@@ -15256,6 +15496,7 @@
           <a:lstStyle xmlns:a="http://schemas.openxmlformats.org/drawingml/2006/main"/>
           <a:p xmlns:a="http://schemas.openxmlformats.org/drawingml/2006/main">
             <a:pPr algn="r">
+              <a:buNone/>
               <a:defRPr sz="825" b="1">
                 <a:solidFill>
                   <a:srgbClr val="687386"/>
@@ -15306,6 +15547,7 @@
           <a:lstStyle xmlns:a="http://schemas.openxmlformats.org/drawingml/2006/main"/>
           <a:p xmlns:a="http://schemas.openxmlformats.org/drawingml/2006/main">
             <a:pPr algn="l">
+              <a:buNone/>
               <a:defRPr sz="900" b="1">
                 <a:solidFill>
                   <a:srgbClr val="18A999"/>
@@ -15356,6 +15598,7 @@
           <a:lstStyle xmlns:a="http://schemas.openxmlformats.org/drawingml/2006/main"/>
           <a:p xmlns:a="http://schemas.openxmlformats.org/drawingml/2006/main">
             <a:pPr algn="l">
+              <a:buNone/>
               <a:defRPr sz="2850" b="1">
                 <a:solidFill>
                   <a:srgbClr val="1B2A4A"/>
@@ -15406,6 +15649,7 @@
           <a:lstStyle xmlns:a="http://schemas.openxmlformats.org/drawingml/2006/main"/>
           <a:p xmlns:a="http://schemas.openxmlformats.org/drawingml/2006/main">
             <a:pPr algn="l">
+              <a:buNone/>
               <a:defRPr sz="1425" b="0">
                 <a:solidFill>
                   <a:srgbClr val="687386"/>
@@ -15425,14 +15669,14 @@
       </p:sp>
       <p:pic>
         <p:nvPicPr>
-          <p:cNvPr id="18" name=""/>
+          <p:cNvPr id="19" name=""/>
           <p:cNvPicPr>
             <a:picLocks xmlns:a="http://schemas.openxmlformats.org/drawingml/2006/main" noChangeAspect="1"/>
           </p:cNvPicPr>
           <p:nvPr/>
         </p:nvPicPr>
         <p:blipFill>
-          <a:blip xmlns:r="http://schemas.openxmlformats.org/officeDocument/2006/relationships" xmlns:a="http://schemas.openxmlformats.org/drawingml/2006/main" r:embed="R7c7b3ef367824779"/>
+          <a:blip xmlns:r="http://schemas.openxmlformats.org/officeDocument/2006/relationships" xmlns:a="http://schemas.openxmlformats.org/drawingml/2006/main" r:embed="Rbcbaa336610346d0"/>
           <a:stretch xmlns:a="http://schemas.openxmlformats.org/drawingml/2006/main"/>
         </p:blipFill>
         <p:spPr>
@@ -15478,6 +15722,7 @@
           <a:lstStyle xmlns:a="http://schemas.openxmlformats.org/drawingml/2006/main"/>
           <a:p xmlns:a="http://schemas.openxmlformats.org/drawingml/2006/main">
             <a:pPr algn="l">
+              <a:buNone/>
               <a:defRPr sz="1275" b="1">
                 <a:solidFill>
                   <a:srgbClr val="1B2A4A"/>
@@ -15528,6 +15773,7 @@
           <a:lstStyle xmlns:a="http://schemas.openxmlformats.org/drawingml/2006/main"/>
           <a:p xmlns:a="http://schemas.openxmlformats.org/drawingml/2006/main">
             <a:pPr algn="l">
+              <a:buNone/>
               <a:defRPr sz="2175" b="1">
                 <a:solidFill>
                   <a:srgbClr val="1B2A4A"/>
@@ -15545,6 +15791,7 @@
           </a:p>
           <a:p xmlns:a="http://schemas.openxmlformats.org/drawingml/2006/main">
             <a:pPr algn="l">
+              <a:buNone/>
               <a:defRPr sz="2175" b="1">
                 <a:solidFill>
                   <a:srgbClr val="1B2A4A"/>
@@ -15595,6 +15842,7 @@
           <a:lstStyle xmlns:a="http://schemas.openxmlformats.org/drawingml/2006/main"/>
           <a:p xmlns:a="http://schemas.openxmlformats.org/drawingml/2006/main">
             <a:pPr algn="l">
+              <a:buNone/>
               <a:defRPr sz="1350" b="0">
                 <a:solidFill>
                   <a:srgbClr val="3F4A59"/>
@@ -15676,6 +15924,7 @@
           <a:lstStyle xmlns:a="http://schemas.openxmlformats.org/drawingml/2006/main"/>
           <a:p xmlns:a="http://schemas.openxmlformats.org/drawingml/2006/main">
             <a:pPr algn="l">
+              <a:buNone/>
               <a:defRPr sz="1275" b="1">
                 <a:solidFill>
                   <a:srgbClr val="18A999"/>
@@ -15726,6 +15975,7 @@
           <a:lstStyle xmlns:a="http://schemas.openxmlformats.org/drawingml/2006/main"/>
           <a:p xmlns:a="http://schemas.openxmlformats.org/drawingml/2006/main">
             <a:pPr algn="l">
+              <a:buNone/>
               <a:defRPr sz="2175" b="1">
                 <a:solidFill>
                   <a:srgbClr val="18A999"/>
@@ -15776,6 +16026,7 @@
           <a:lstStyle xmlns:a="http://schemas.openxmlformats.org/drawingml/2006/main"/>
           <a:p xmlns:a="http://schemas.openxmlformats.org/drawingml/2006/main">
             <a:pPr algn="l">
+              <a:buNone/>
               <a:defRPr sz="1350" b="0">
                 <a:solidFill>
                   <a:srgbClr val="3F4A59"/>
@@ -15826,6 +16077,7 @@
           <a:lstStyle xmlns:a="http://schemas.openxmlformats.org/drawingml/2006/main"/>
           <a:p xmlns:a="http://schemas.openxmlformats.org/drawingml/2006/main">
             <a:pPr algn="l">
+              <a:buNone/>
               <a:defRPr sz="675" b="0">
                 <a:solidFill>
                   <a:srgbClr val="687386"/>

</xml_diff>